<commit_message>
style: enhance PPTX with rounded corners, larger fonts, and expanded line spacing
</commit_message>
<xml_diff>
--- a/Eco-Drain_WEFE_Nexus_5Min_Pitch.pptx
+++ b/Eco-Drain_WEFE_Nexus_5Min_Pitch.pptx
@@ -3135,14 +3135,116 @@
       </p:sp>
       <p:sp>
         <p:nvSpPr>
-          <p:cNvPr id="3" name="TextBox 2"/>
+          <p:cNvPr id="3" name="Rounded Rectangle 2"/>
+          <p:cNvSpPr/>
+          <p:nvPr/>
+        </p:nvSpPr>
+        <p:spPr>
+          <a:xfrm>
+            <a:off x="731520" y="146304"/>
+            <a:ext cx="10728655" cy="36576"/>
+          </a:xfrm>
+          <a:prstGeom prst="roundRect">
+            <a:avLst>
+              <a:gd name="adj" fmla="val 50000"/>
+            </a:avLst>
+          </a:prstGeom>
+          <a:solidFill>
+            <a:srgbClr val="15B5A4"/>
+          </a:solidFill>
+          <a:ln>
+            <a:noFill/>
+          </a:ln>
+        </p:spPr>
+        <p:style>
+          <a:lnRef idx="1">
+            <a:schemeClr val="accent1"/>
+          </a:lnRef>
+          <a:fillRef idx="3">
+            <a:schemeClr val="accent1"/>
+          </a:fillRef>
+          <a:effectRef idx="2">
+            <a:schemeClr val="accent1"/>
+          </a:effectRef>
+          <a:fontRef idx="minor">
+            <a:schemeClr val="lt1"/>
+          </a:fontRef>
+        </p:style>
+        <p:txBody>
+          <a:bodyPr rtlCol="0" anchor="ctr"/>
+          <a:lstStyle/>
+          <a:p>
+            <a:pPr algn="ctr"/>
+          </a:p>
+        </p:txBody>
+      </p:sp>
+      <p:sp>
+        <p:nvSpPr>
+          <p:cNvPr id="4" name="Rounded Rectangle 3"/>
+          <p:cNvSpPr/>
+          <p:nvPr/>
+        </p:nvSpPr>
+        <p:spPr>
+          <a:xfrm>
+            <a:off x="7253935" y="292608"/>
+            <a:ext cx="4206240" cy="292608"/>
+          </a:xfrm>
+          <a:prstGeom prst="roundRect">
+            <a:avLst>
+              <a:gd name="adj" fmla="val 50000"/>
+            </a:avLst>
+          </a:prstGeom>
+          <a:solidFill>
+            <a:srgbClr val="162D52"/>
+          </a:solidFill>
+          <a:ln w="15240">
+            <a:solidFill>
+              <a:srgbClr val="15B5A4"/>
+            </a:solidFill>
+          </a:ln>
+        </p:spPr>
+        <p:style>
+          <a:lnRef idx="1">
+            <a:schemeClr val="accent1"/>
+          </a:lnRef>
+          <a:fillRef idx="3">
+            <a:schemeClr val="accent1"/>
+          </a:fillRef>
+          <a:effectRef idx="2">
+            <a:schemeClr val="accent1"/>
+          </a:effectRef>
+          <a:fontRef idx="minor">
+            <a:schemeClr val="lt1"/>
+          </a:fontRef>
+        </p:style>
+        <p:txBody>
+          <a:bodyPr rtlCol="0" anchor="ctr" wrap="none" tIns="0" bIns="0" lIns="0" rIns="0"/>
+          <a:lstStyle/>
+          <a:p>
+            <a:pPr algn="ctr">
+              <a:defRPr sz="1050" b="1">
+                <a:solidFill>
+                  <a:srgbClr val="15B5A4"/>
+                </a:solidFill>
+                <a:latin typeface="Segoe UI"/>
+              </a:defRPr>
+            </a:pPr>
+            <a:r>
+              <a:t>الشريحة 1 من 3 | عرض تنفيذي في 5 دقائق | محور WEFE المقاوم للمناخ</a:t>
+            </a:r>
+          </a:p>
+        </p:txBody>
+      </p:sp>
+      <p:sp>
+        <p:nvSpPr>
+          <p:cNvPr id="5" name="TextBox 4"/>
           <p:cNvSpPr txBox="1"/>
           <p:nvPr/>
         </p:nvSpPr>
         <p:spPr>
           <a:xfrm>
-            <a:off x="731520" y="365760"/>
-            <a:ext cx="10728655" cy="1051560"/>
+            <a:off x="731520" y="658368"/>
+            <a:ext cx="10728655" cy="804672"/>
           </a:xfrm>
           <a:prstGeom prst="rect">
             <a:avLst/>
@@ -3156,58 +3258,633 @@
           <a:lstStyle/>
           <a:p>
             <a:pPr algn="r">
-              <a:defRPr sz="950" b="1">
-                <a:solidFill>
-                  <a:srgbClr val="15B5A4"/>
-                </a:solidFill>
+              <a:lnSpc>
+                <a:spcPct val="115000"/>
+              </a:lnSpc>
+              <a:defRPr sz="2200" b="1">
+                <a:solidFill>
+                  <a:srgbClr val="F8FAFC"/>
+                </a:solidFill>
+                <a:latin typeface="Segoe UI"/>
               </a:defRPr>
             </a:pPr>
             <a:r>
-              <a:t>الشريحة 1 من 3 | عرض تنفيذي في 5 دقائق | برنامج تمويل المرونة ومحور WEFE</a:t>
+              <a:t>إيكو-درين (Eco-Drain): إحلال وتجديد شبكات الصرف المغطى الذكية ومقاومة التلاعب</a:t>
             </a:r>
           </a:p>
           <a:p>
             <a:pPr algn="r">
-              <a:defRPr sz="1900" b="1">
-                <a:solidFill>
-                  <a:srgbClr val="F8FAFC"/>
-                </a:solidFill>
+              <a:lnSpc>
+                <a:spcPct val="120000"/>
+              </a:lnSpc>
+              <a:defRPr sz="1200">
+                <a:solidFill>
+                  <a:srgbClr val="F0C860"/>
+                </a:solidFill>
+                <a:latin typeface="Segoe UI"/>
               </a:defRPr>
             </a:pPr>
             <a:r>
-              <a:t>إيكو-درين (Eco-Drain): إحلال وتجديد شبكات الصرف المغطى الذكية ومقاومة التلاعب</a:t>
-            </a:r>
-          </a:p>
-          <a:p>
-            <a:pPr algn="r">
-              <a:defRPr sz="1100">
-                <a:solidFill>
-                  <a:srgbClr val="F0C860"/>
-                </a:solidFill>
-              </a:defRPr>
-            </a:pPr>
-            <a:r>
-              <a:t>1. عنوان المشروع والأزمة الهيدروليكية | 3. الجهة القائدة، الشركاء وهيكل الحوكمة</a:t>
-            </a:r>
-          </a:p>
-        </p:txBody>
-      </p:sp>
-      <p:sp>
-        <p:nvSpPr>
-          <p:cNvPr id="4" name="Rounded Rectangle 3"/>
+              <a:t>1. بيان المشكلة المائية وتحدي التلاعب | 3. الجهة القائدة، الشركاء وهيكل الحوكمة المؤسسية</a:t>
+            </a:r>
+          </a:p>
+        </p:txBody>
+      </p:sp>
+      <p:sp>
+        <p:nvSpPr>
+          <p:cNvPr id="6" name="Rounded Rectangle 5"/>
           <p:cNvSpPr/>
           <p:nvPr/>
         </p:nvSpPr>
         <p:spPr>
           <a:xfrm>
-            <a:off x="6217920" y="1463040"/>
+            <a:off x="6217920" y="1536192"/>
             <a:ext cx="5242255" cy="2377440"/>
           </a:xfrm>
           <a:prstGeom prst="roundRect">
-            <a:avLst/>
+            <a:avLst>
+              <a:gd name="adj" fmla="val 8000"/>
+            </a:avLst>
           </a:prstGeom>
           <a:solidFill>
             <a:srgbClr val="0F2240"/>
+          </a:solidFill>
+          <a:ln w="16510">
+            <a:solidFill>
+              <a:srgbClr val="EF4444"/>
+            </a:solidFill>
+          </a:ln>
+        </p:spPr>
+        <p:style>
+          <a:lnRef idx="1">
+            <a:schemeClr val="accent1"/>
+          </a:lnRef>
+          <a:fillRef idx="3">
+            <a:schemeClr val="accent1"/>
+          </a:fillRef>
+          <a:effectRef idx="2">
+            <a:schemeClr val="accent1"/>
+          </a:effectRef>
+          <a:fontRef idx="minor">
+            <a:schemeClr val="lt1"/>
+          </a:fontRef>
+        </p:style>
+        <p:txBody>
+          <a:bodyPr rtlCol="0" anchor="ctr"/>
+          <a:lstStyle/>
+          <a:p>
+            <a:pPr algn="ctr"/>
+          </a:p>
+        </p:txBody>
+      </p:sp>
+      <p:sp>
+        <p:nvSpPr>
+          <p:cNvPr id="7" name="TextBox 6"/>
+          <p:cNvSpPr txBox="1"/>
+          <p:nvPr/>
+        </p:nvSpPr>
+        <p:spPr>
+          <a:xfrm>
+            <a:off x="6419088" y="1645920"/>
+            <a:ext cx="4839919" cy="347472"/>
+          </a:xfrm>
+          <a:prstGeom prst="rect">
+            <a:avLst/>
+          </a:prstGeom>
+          <a:noFill/>
+        </p:spPr>
+        <p:txBody>
+          <a:bodyPr wrap="square" tIns="0" bIns="0" lIns="0" rIns="0">
+            <a:spAutoFit/>
+          </a:bodyPr>
+          <a:lstStyle/>
+          <a:p>
+            <a:pPr algn="r">
+              <a:defRPr sz="1450" b="1">
+                <a:solidFill>
+                  <a:srgbClr val="EF4444"/>
+                </a:solidFill>
+                <a:latin typeface="Segoe UI"/>
+              </a:defRPr>
+            </a:pPr>
+            <a:r>
+              <a:t>🚨 1. بيان المشكلة المائية وتدهور الشبكات بالدلتا</a:t>
+            </a:r>
+          </a:p>
+        </p:txBody>
+      </p:sp>
+      <p:sp>
+        <p:nvSpPr>
+          <p:cNvPr id="8" name="Rounded Rectangle 7"/>
+          <p:cNvSpPr/>
+          <p:nvPr/>
+        </p:nvSpPr>
+        <p:spPr>
+          <a:xfrm>
+            <a:off x="6400800" y="1975104"/>
+            <a:ext cx="4876495" cy="310896"/>
+          </a:xfrm>
+          <a:prstGeom prst="roundRect">
+            <a:avLst>
+              <a:gd name="adj" fmla="val 35000"/>
+            </a:avLst>
+          </a:prstGeom>
+          <a:solidFill>
+            <a:srgbClr val="162D52"/>
+          </a:solidFill>
+          <a:ln w="12700">
+            <a:solidFill>
+              <a:srgbClr val="EF4444"/>
+            </a:solidFill>
+          </a:ln>
+        </p:spPr>
+        <p:style>
+          <a:lnRef idx="1">
+            <a:schemeClr val="accent1"/>
+          </a:lnRef>
+          <a:fillRef idx="3">
+            <a:schemeClr val="accent1"/>
+          </a:fillRef>
+          <a:effectRef idx="2">
+            <a:schemeClr val="accent1"/>
+          </a:effectRef>
+          <a:fontRef idx="minor">
+            <a:schemeClr val="lt1"/>
+          </a:fontRef>
+        </p:style>
+        <p:txBody>
+          <a:bodyPr rtlCol="0" anchor="ctr" wrap="square" tIns="0" bIns="0" lIns="0" rIns="0"/>
+          <a:lstStyle/>
+          <a:p>
+            <a:pPr algn="r">
+              <a:defRPr sz="1150" b="1">
+                <a:solidFill>
+                  <a:srgbClr val="F0C860"/>
+                </a:solidFill>
+                <a:latin typeface="Segoe UI"/>
+              </a:defRPr>
+            </a:pPr>
+            <a:r>
+              <a:t> ⚠️ 560 م³/فرد حصة حرجة | 2.3 مليون فدان متقادمة </a:t>
+            </a:r>
+          </a:p>
+        </p:txBody>
+      </p:sp>
+      <p:sp>
+        <p:nvSpPr>
+          <p:cNvPr id="9" name="TextBox 8"/>
+          <p:cNvSpPr txBox="1"/>
+          <p:nvPr/>
+        </p:nvSpPr>
+        <p:spPr>
+          <a:xfrm>
+            <a:off x="6419088" y="2340864"/>
+            <a:ext cx="4839919" cy="1481328"/>
+          </a:xfrm>
+          <a:prstGeom prst="rect">
+            <a:avLst/>
+          </a:prstGeom>
+          <a:noFill/>
+        </p:spPr>
+        <p:txBody>
+          <a:bodyPr wrap="square" tIns="0" bIns="0" lIns="0" rIns="0">
+            <a:spAutoFit/>
+          </a:bodyPr>
+          <a:lstStyle/>
+          <a:p>
+            <a:pPr algn="r">
+              <a:lnSpc>
+                <a:spcPct val="125000"/>
+              </a:lnSpc>
+              <a:spcAft>
+                <a:spcPts val="600"/>
+              </a:spcAft>
+            </a:pPr>
+            <a:r>
+              <a:rPr sz="1150" b="1">
+                <a:solidFill>
+                  <a:srgbClr val="F0C860"/>
+                </a:solidFill>
+                <a:latin typeface="Segoe UI"/>
+              </a:rPr>
+              <a:t>• الفقر المائي الحرج: </a:t>
+            </a:r>
+            <a:r>
+              <a:rPr sz="1150">
+                <a:solidFill>
+                  <a:srgbClr val="F8FAFC"/>
+                </a:solidFill>
+                <a:latin typeface="Segoe UI"/>
+              </a:rPr>
+              <a:t>حصة مصر 55.5 مليار م³ لـ 106+ مليون نسمة (560 م³/فرد، أقل بكثير من حد الفقر العالمي 1,000 م³).</a:t>
+            </a:r>
+          </a:p>
+          <a:p>
+            <a:pPr algn="r">
+              <a:lnSpc>
+                <a:spcPct val="125000"/>
+              </a:lnSpc>
+              <a:spcAft>
+                <a:spcPts val="600"/>
+              </a:spcAft>
+            </a:pPr>
+            <a:r>
+              <a:rPr sz="1150" b="1">
+                <a:solidFill>
+                  <a:srgbClr val="F0C860"/>
+                </a:solidFill>
+                <a:latin typeface="Segoe UI"/>
+              </a:rPr>
+              <a:t>• تقادم 2.3 مليون فدان: </a:t>
+            </a:r>
+            <a:r>
+              <a:rPr sz="1150">
+                <a:solidFill>
+                  <a:srgbClr val="F8FAFC"/>
+                </a:solidFill>
+                <a:latin typeface="Segoe UI"/>
+              </a:rPr>
+              <a:t>شبكات الصرف تجاوزت عمرها (20-25 سنة)، مسببة تغدق الجذور وتملح التربة وخسارة 10-30% من المحاصيل.</a:t>
+            </a:r>
+          </a:p>
+          <a:p>
+            <a:pPr algn="r">
+              <a:lnSpc>
+                <a:spcPct val="125000"/>
+              </a:lnSpc>
+              <a:spcAft>
+                <a:spcPts val="0"/>
+              </a:spcAft>
+            </a:pPr>
+            <a:r>
+              <a:rPr sz="1150" b="1">
+                <a:solidFill>
+                  <a:srgbClr val="F0C860"/>
+                </a:solidFill>
+                <a:latin typeface="Segoe UI"/>
+              </a:rPr>
+              <a:t>• أزمة البنية غير المرئية: </a:t>
+            </a:r>
+            <a:r>
+              <a:rPr sz="1150">
+                <a:solidFill>
+                  <a:srgbClr val="F8FAFC"/>
+                </a:solidFill>
+                <a:latin typeface="Segoe UI"/>
+              </a:rPr>
+              <a:t>شبكات مدفونة تحت الأرض يصعب فحصها بصرياً وتتأخر صيانتها لسنوات حتى يتلف المحصول.</a:t>
+            </a:r>
+          </a:p>
+        </p:txBody>
+      </p:sp>
+      <p:sp>
+        <p:nvSpPr>
+          <p:cNvPr id="10" name="Rounded Rectangle 9"/>
+          <p:cNvSpPr/>
+          <p:nvPr/>
+        </p:nvSpPr>
+        <p:spPr>
+          <a:xfrm>
+            <a:off x="6217920" y="4069080"/>
+            <a:ext cx="5242255" cy="2423160"/>
+          </a:xfrm>
+          <a:prstGeom prst="roundRect">
+            <a:avLst>
+              <a:gd name="adj" fmla="val 8000"/>
+            </a:avLst>
+          </a:prstGeom>
+          <a:solidFill>
+            <a:srgbClr val="0F2240"/>
+          </a:solidFill>
+          <a:ln w="16510">
+            <a:solidFill>
+              <a:srgbClr val="D4A843"/>
+            </a:solidFill>
+          </a:ln>
+        </p:spPr>
+        <p:style>
+          <a:lnRef idx="1">
+            <a:schemeClr val="accent1"/>
+          </a:lnRef>
+          <a:fillRef idx="3">
+            <a:schemeClr val="accent1"/>
+          </a:fillRef>
+          <a:effectRef idx="2">
+            <a:schemeClr val="accent1"/>
+          </a:effectRef>
+          <a:fontRef idx="minor">
+            <a:schemeClr val="lt1"/>
+          </a:fontRef>
+        </p:style>
+        <p:txBody>
+          <a:bodyPr rtlCol="0" anchor="ctr"/>
+          <a:lstStyle/>
+          <a:p>
+            <a:pPr algn="ctr"/>
+          </a:p>
+        </p:txBody>
+      </p:sp>
+      <p:sp>
+        <p:nvSpPr>
+          <p:cNvPr id="11" name="TextBox 10"/>
+          <p:cNvSpPr txBox="1"/>
+          <p:nvPr/>
+        </p:nvSpPr>
+        <p:spPr>
+          <a:xfrm>
+            <a:off x="6419088" y="4178808"/>
+            <a:ext cx="4839919" cy="347472"/>
+          </a:xfrm>
+          <a:prstGeom prst="rect">
+            <a:avLst/>
+          </a:prstGeom>
+          <a:noFill/>
+        </p:spPr>
+        <p:txBody>
+          <a:bodyPr wrap="square" tIns="0" bIns="0" lIns="0" rIns="0">
+            <a:spAutoFit/>
+          </a:bodyPr>
+          <a:lstStyle/>
+          <a:p>
+            <a:pPr algn="r">
+              <a:defRPr sz="1450" b="1">
+                <a:solidFill>
+                  <a:srgbClr val="F0C860"/>
+                </a:solidFill>
+                <a:latin typeface="Segoe UI"/>
+              </a:defRPr>
+            </a:pPr>
+            <a:r>
+              <a:t>🛡️ 2. تحدي التلاعب الزراعي وابتكار الغرف غير المرئية</a:t>
+            </a:r>
+          </a:p>
+        </p:txBody>
+      </p:sp>
+      <p:sp>
+        <p:nvSpPr>
+          <p:cNvPr id="12" name="Rounded Rectangle 11"/>
+          <p:cNvSpPr/>
+          <p:nvPr/>
+        </p:nvSpPr>
+        <p:spPr>
+          <a:xfrm>
+            <a:off x="6400800" y="4507992"/>
+            <a:ext cx="4876495" cy="310896"/>
+          </a:xfrm>
+          <a:prstGeom prst="roundRect">
+            <a:avLst>
+              <a:gd name="adj" fmla="val 35000"/>
+            </a:avLst>
+          </a:prstGeom>
+          <a:solidFill>
+            <a:srgbClr val="162D52"/>
+          </a:solidFill>
+          <a:ln w="12700">
+            <a:solidFill>
+              <a:srgbClr val="D4A843"/>
+            </a:solidFill>
+          </a:ln>
+        </p:spPr>
+        <p:style>
+          <a:lnRef idx="1">
+            <a:schemeClr val="accent1"/>
+          </a:lnRef>
+          <a:fillRef idx="3">
+            <a:schemeClr val="accent1"/>
+          </a:fillRef>
+          <a:effectRef idx="2">
+            <a:schemeClr val="accent1"/>
+          </a:effectRef>
+          <a:fontRef idx="minor">
+            <a:schemeClr val="lt1"/>
+          </a:fontRef>
+        </p:style>
+        <p:txBody>
+          <a:bodyPr rtlCol="0" anchor="ctr" wrap="square" tIns="0" bIns="0" lIns="0" rIns="0"/>
+          <a:lstStyle/>
+          <a:p>
+            <a:pPr algn="r">
+              <a:defRPr sz="1150" b="1">
+                <a:solidFill>
+                  <a:srgbClr val="15B5A4"/>
+                </a:solidFill>
+                <a:latin typeface="Segoe UI"/>
+              </a:defRPr>
+            </a:pPr>
+            <a:r>
+              <a:t> 🔒 غرف غاطسة مدفونة 30-50 سم | رصد اهتزاز &gt;2.5g وإنذار NB-IoT </a:t>
+            </a:r>
+          </a:p>
+        </p:txBody>
+      </p:sp>
+      <p:sp>
+        <p:nvSpPr>
+          <p:cNvPr id="13" name="TextBox 12"/>
+          <p:cNvSpPr txBox="1"/>
+          <p:nvPr/>
+        </p:nvSpPr>
+        <p:spPr>
+          <a:xfrm>
+            <a:off x="6419088" y="4873752"/>
+            <a:ext cx="4839919" cy="1527048"/>
+          </a:xfrm>
+          <a:prstGeom prst="rect">
+            <a:avLst/>
+          </a:prstGeom>
+          <a:noFill/>
+        </p:spPr>
+        <p:txBody>
+          <a:bodyPr wrap="square" tIns="0" bIns="0" lIns="0" rIns="0">
+            <a:spAutoFit/>
+          </a:bodyPr>
+          <a:lstStyle/>
+          <a:p>
+            <a:pPr algn="r">
+              <a:lnSpc>
+                <a:spcPct val="125000"/>
+              </a:lnSpc>
+              <a:spcAft>
+                <a:spcPts val="600"/>
+              </a:spcAft>
+            </a:pPr>
+            <a:r>
+              <a:rPr sz="1150" b="1">
+                <a:solidFill>
+                  <a:srgbClr val="F0C860"/>
+                </a:solidFill>
+                <a:latin typeface="Segoe UI"/>
+              </a:rPr>
+              <a:t>• التعديات العشوائية: </a:t>
+            </a:r>
+            <a:r>
+              <a:rPr sz="1150">
+                <a:solidFill>
+                  <a:srgbClr val="F8FAFC"/>
+                </a:solidFill>
+                <a:latin typeface="Segoe UI"/>
+              </a:rPr>
+              <a:t>سجلات هيئة الصرف توثق أن 25-40% من الأعطال ناجمة عن سد المزارعين للمناهل لحبس المياه لزراعة الأرز.</a:t>
+            </a:r>
+          </a:p>
+          <a:p>
+            <a:pPr algn="r">
+              <a:lnSpc>
+                <a:spcPct val="125000"/>
+              </a:lnSpc>
+              <a:spcAft>
+                <a:spcPts val="600"/>
+              </a:spcAft>
+            </a:pPr>
+            <a:r>
+              <a:rPr sz="1150" b="1">
+                <a:solidFill>
+                  <a:srgbClr val="F0C860"/>
+                </a:solidFill>
+                <a:latin typeface="Segoe UI"/>
+              </a:rPr>
+              <a:t>• ابتكار الغرف الغاطسة: </a:t>
+            </a:r>
+            <a:r>
+              <a:rPr sz="1150">
+                <a:solidFill>
+                  <a:srgbClr val="F8FAFC"/>
+                </a:solidFill>
+                <a:latin typeface="Segoe UI"/>
+              </a:rPr>
+              <a:t>استبدال الغرف السطحية بغرف مدفونة 30-50 سم مع شرائح RFID وإحداثيات GPS تمنع التلاعب نهائياً.</a:t>
+            </a:r>
+          </a:p>
+          <a:p>
+            <a:pPr algn="r">
+              <a:lnSpc>
+                <a:spcPct val="125000"/>
+              </a:lnSpc>
+              <a:spcAft>
+                <a:spcPts val="0"/>
+              </a:spcAft>
+            </a:pPr>
+            <a:r>
+              <a:rPr sz="1150" b="1">
+                <a:solidFill>
+                  <a:srgbClr val="F0C860"/>
+                </a:solidFill>
+                <a:latin typeface="Segoe UI"/>
+              </a:rPr>
+              <a:t>• الردع الذكي الفوري: </a:t>
+            </a:r>
+            <a:r>
+              <a:rPr sz="1150">
+                <a:solidFill>
+                  <a:srgbClr val="F8FAFC"/>
+                </a:solidFill>
+                <a:latin typeface="Segoe UI"/>
+              </a:rPr>
+              <a:t>حساسات MPU6050 ترصد أي اهتزاز أو حفر (&gt;2.5g) وتبث إنذار طوارئ مشفر (AES-128) عبر NB-IoT إلى مركز التحكم.</a:t>
+            </a:r>
+          </a:p>
+        </p:txBody>
+      </p:sp>
+      <p:sp>
+        <p:nvSpPr>
+          <p:cNvPr id="14" name="Rounded Rectangle 13"/>
+          <p:cNvSpPr/>
+          <p:nvPr/>
+        </p:nvSpPr>
+        <p:spPr>
+          <a:xfrm>
+            <a:off x="731520" y="1536192"/>
+            <a:ext cx="5212080" cy="4956048"/>
+          </a:xfrm>
+          <a:prstGeom prst="roundRect">
+            <a:avLst>
+              <a:gd name="adj" fmla="val 6000"/>
+            </a:avLst>
+          </a:prstGeom>
+          <a:solidFill>
+            <a:srgbClr val="0F2240"/>
+          </a:solidFill>
+          <a:ln w="16510">
+            <a:solidFill>
+              <a:srgbClr val="15B5A4"/>
+            </a:solidFill>
+          </a:ln>
+        </p:spPr>
+        <p:style>
+          <a:lnRef idx="1">
+            <a:schemeClr val="accent1"/>
+          </a:lnRef>
+          <a:fillRef idx="3">
+            <a:schemeClr val="accent1"/>
+          </a:fillRef>
+          <a:effectRef idx="2">
+            <a:schemeClr val="accent1"/>
+          </a:effectRef>
+          <a:fontRef idx="minor">
+            <a:schemeClr val="lt1"/>
+          </a:fontRef>
+        </p:style>
+        <p:txBody>
+          <a:bodyPr rtlCol="0" anchor="ctr"/>
+          <a:lstStyle/>
+          <a:p>
+            <a:pPr algn="ctr"/>
+          </a:p>
+        </p:txBody>
+      </p:sp>
+      <p:sp>
+        <p:nvSpPr>
+          <p:cNvPr id="15" name="TextBox 14"/>
+          <p:cNvSpPr txBox="1"/>
+          <p:nvPr/>
+        </p:nvSpPr>
+        <p:spPr>
+          <a:xfrm>
+            <a:off x="932688" y="1645920"/>
+            <a:ext cx="4809744" cy="347472"/>
+          </a:xfrm>
+          <a:prstGeom prst="rect">
+            <a:avLst/>
+          </a:prstGeom>
+          <a:noFill/>
+        </p:spPr>
+        <p:txBody>
+          <a:bodyPr wrap="square" tIns="0" bIns="0" lIns="0" rIns="0">
+            <a:spAutoFit/>
+          </a:bodyPr>
+          <a:lstStyle/>
+          <a:p>
+            <a:pPr algn="r">
+              <a:defRPr sz="1450" b="1">
+                <a:solidFill>
+                  <a:srgbClr val="15B5A4"/>
+                </a:solidFill>
+                <a:latin typeface="Segoe UI"/>
+              </a:defRPr>
+            </a:pPr>
+            <a:r>
+              <a:t>🏛️ 3. الجهة القائدة، الشركاء وهيكل الحوكمة المؤسسية</a:t>
+            </a:r>
+          </a:p>
+        </p:txBody>
+      </p:sp>
+      <p:sp>
+        <p:nvSpPr>
+          <p:cNvPr id="16" name="Rounded Rectangle 15"/>
+          <p:cNvSpPr/>
+          <p:nvPr/>
+        </p:nvSpPr>
+        <p:spPr>
+          <a:xfrm>
+            <a:off x="914400" y="1975104"/>
+            <a:ext cx="4846320" cy="310896"/>
+          </a:xfrm>
+          <a:prstGeom prst="roundRect">
+            <a:avLst>
+              <a:gd name="adj" fmla="val 35000"/>
+            </a:avLst>
+          </a:prstGeom>
+          <a:solidFill>
+            <a:srgbClr val="162D52"/>
           </a:solidFill>
           <a:ln w="12700">
             <a:solidFill>
@@ -3230,23 +3907,33 @@
           </a:fontRef>
         </p:style>
         <p:txBody>
-          <a:bodyPr rtlCol="0" anchor="ctr"/>
-          <a:lstStyle/>
-          <a:p>
-            <a:pPr algn="ctr"/>
-          </a:p>
-        </p:txBody>
-      </p:sp>
-      <p:sp>
-        <p:nvSpPr>
-          <p:cNvPr id="5" name="TextBox 4"/>
+          <a:bodyPr rtlCol="0" anchor="ctr" wrap="square" tIns="0" bIns="0" lIns="0" rIns="0"/>
+          <a:lstStyle/>
+          <a:p>
+            <a:pPr algn="r">
+              <a:defRPr sz="1150" b="1">
+                <a:solidFill>
+                  <a:srgbClr val="F0C860"/>
+                </a:solidFill>
+                <a:latin typeface="Segoe UI"/>
+              </a:defRPr>
+            </a:pPr>
+            <a:r>
+              <a:t> 👑 قيادة تنفيذية: وزارة الموارد المائية والري (MWRI) / هيئة الصرف (EPADP) </a:t>
+            </a:r>
+          </a:p>
+        </p:txBody>
+      </p:sp>
+      <p:sp>
+        <p:nvSpPr>
+          <p:cNvPr id="17" name="TextBox 16"/>
           <p:cNvSpPr txBox="1"/>
           <p:nvPr/>
         </p:nvSpPr>
         <p:spPr>
           <a:xfrm>
-            <a:off x="6400800" y="1600200"/>
-            <a:ext cx="4876495" cy="365760"/>
+            <a:off x="932688" y="2340864"/>
+            <a:ext cx="4809744" cy="4059936"/>
           </a:xfrm>
           <a:prstGeom prst="rect">
             <a:avLst/>
@@ -3260,395 +3947,170 @@
           <a:lstStyle/>
           <a:p>
             <a:pPr algn="r">
-              <a:defRPr sz="1200" b="1">
-                <a:solidFill>
-                  <a:srgbClr val="EF4444"/>
-                </a:solidFill>
-              </a:defRPr>
-            </a:pPr>
-            <a:r>
-              <a:t>🚨 1. بيان المشكلة المائية وتدهور الشبكات بالدلتا</a:t>
-            </a:r>
-          </a:p>
-        </p:txBody>
-      </p:sp>
-      <p:sp>
-        <p:nvSpPr>
-          <p:cNvPr id="6" name="TextBox 5"/>
-          <p:cNvSpPr txBox="1"/>
-          <p:nvPr/>
-        </p:nvSpPr>
-        <p:spPr>
-          <a:xfrm>
-            <a:off x="6400800" y="1965960"/>
-            <a:ext cx="4876495" cy="1783080"/>
-          </a:xfrm>
-          <a:prstGeom prst="rect">
-            <a:avLst/>
-          </a:prstGeom>
-          <a:noFill/>
-        </p:spPr>
-        <p:txBody>
-          <a:bodyPr wrap="square" tIns="0" bIns="0" lIns="0" rIns="0">
-            <a:spAutoFit/>
-          </a:bodyPr>
-          <a:lstStyle/>
+              <a:lnSpc>
+                <a:spcPct val="125000"/>
+              </a:lnSpc>
+              <a:spcAft>
+                <a:spcPts val="700"/>
+              </a:spcAft>
+            </a:pPr>
+            <a:r>
+              <a:rPr sz="1150" b="1">
+                <a:solidFill>
+                  <a:srgbClr val="F0C860"/>
+                </a:solidFill>
+                <a:latin typeface="Segoe UI"/>
+              </a:rPr>
+              <a:t>• الجهة القائدة التنفيذية: </a:t>
+            </a:r>
+            <a:r>
+              <a:rPr sz="1150">
+                <a:solidFill>
+                  <a:srgbClr val="F8FAFC"/>
+                </a:solidFill>
+                <a:latin typeface="Segoe UI"/>
+              </a:rPr>
+              <a:t>الهيئة المصرية العامة لمشروعات الصرف (EPADP - المكتب الفني للوجه البحري) بخبرة 50 عاماً في إدارة الشبكات.</a:t>
+            </a:r>
+          </a:p>
           <a:p>
             <a:pPr algn="r">
-              <a:defRPr sz="950">
+              <a:lnSpc>
+                <a:spcPct val="125000"/>
+              </a:lnSpc>
+              <a:spcAft>
+                <a:spcPts val="600"/>
+              </a:spcAft>
+            </a:pPr>
+            <a:r>
+              <a:rPr sz="1150" b="1">
+                <a:solidFill>
+                  <a:srgbClr val="15B5A4"/>
+                </a:solidFill>
+                <a:latin typeface="Segoe UI"/>
+              </a:rPr>
+              <a:t>• الشركاء الفنيون والزراعيون: </a:t>
+            </a:r>
+            <a:r>
+              <a:rPr sz="1150">
                 <a:solidFill>
                   <a:srgbClr val="F8FAFC"/>
                 </a:solidFill>
-              </a:defRPr>
-            </a:pPr>
-            <a:r>
-              <a:t>• الفقر المائي الحرج: حصة مصر الثابتة 55.5 مليار م³ لـ 106+ مليون نسمة تعني نصيب فرد 560 م³/سنة (تحت خط الفقر المائي العالمي 1,000 م³).</a:t>
+                <a:latin typeface="Segoe UI"/>
+              </a:rPr>
+              <a:t>معهد بحوث الصرف (DRI) للمواصفات والتحقق، ووزارة الزراعة (MALR) لتحسين إنتاجية المحاصيل.</a:t>
             </a:r>
           </a:p>
           <a:p>
             <a:pPr algn="r">
-              <a:defRPr sz="950">
+              <a:lnSpc>
+                <a:spcPct val="125000"/>
+              </a:lnSpc>
+              <a:spcAft>
+                <a:spcPts val="600"/>
+              </a:spcAft>
+            </a:pPr>
+            <a:r>
+              <a:rPr sz="1150" b="1">
+                <a:solidFill>
+                  <a:srgbClr val="15B5A4"/>
+                </a:solidFill>
+                <a:latin typeface="Segoe UI"/>
+              </a:rPr>
+              <a:t>• شريك الطاقة والربط الشبكي: </a:t>
+            </a:r>
+            <a:r>
+              <a:rPr sz="1150">
                 <a:solidFill>
                   <a:srgbClr val="F8FAFC"/>
                 </a:solidFill>
-              </a:defRPr>
-            </a:pPr>
-            <a:r>
-              <a:t>• 2.3 مليون فدان متقادمة: شبكات الصرف المغطى تجاوزت عمرها التصميمي (20-25 سنة) مسببة تغدق الجذور وتملح التربة وخسارة 10-30% من المحاصيل.</a:t>
+                <a:latin typeface="Segoe UI"/>
+              </a:rPr>
+              <a:t>هيئة الطاقة المتجددة (NREA) وجهاز تنظيم الكهرباء (EgyptERA) لتطبيق صافي القياس (Net Metering).</a:t>
             </a:r>
           </a:p>
           <a:p>
             <a:pPr algn="r">
-              <a:defRPr sz="950">
+              <a:lnSpc>
+                <a:spcPct val="125000"/>
+              </a:lnSpc>
+              <a:spcAft>
+                <a:spcPts val="600"/>
+              </a:spcAft>
+            </a:pPr>
+            <a:r>
+              <a:rPr sz="1150" b="1">
+                <a:solidFill>
+                  <a:srgbClr val="15B5A4"/>
+                </a:solidFill>
+                <a:latin typeface="Segoe UI"/>
+              </a:rPr>
+              <a:t>• الحوكمة المجتمعية والميدانية: </a:t>
+            </a:r>
+            <a:r>
+              <a:rPr sz="1150">
                 <a:solidFill>
                   <a:srgbClr val="F8FAFC"/>
                 </a:solidFill>
-              </a:defRPr>
-            </a:pPr>
-            <a:r>
-              <a:t>• أزمة البنية غير المرئية: الشبكات مدفونة تحت الأرض؛ لا يمكن فحصها بصرياً وتتأخر الصيانة لسنوات حتى تظهر أعراض تلف المحصول.</a:t>
-            </a:r>
-          </a:p>
-        </p:txBody>
-      </p:sp>
-      <p:sp>
-        <p:nvSpPr>
-          <p:cNvPr id="7" name="Rounded Rectangle 6"/>
-          <p:cNvSpPr/>
-          <p:nvPr/>
-        </p:nvSpPr>
-        <p:spPr>
-          <a:xfrm>
-            <a:off x="6217920" y="3977639"/>
-            <a:ext cx="5242255" cy="2423160"/>
-          </a:xfrm>
-          <a:prstGeom prst="roundRect">
-            <a:avLst/>
-          </a:prstGeom>
-          <a:solidFill>
-            <a:srgbClr val="0F2240"/>
-          </a:solidFill>
-          <a:ln w="12700">
-            <a:solidFill>
-              <a:srgbClr val="15B5A4"/>
-            </a:solidFill>
-          </a:ln>
-        </p:spPr>
-        <p:style>
-          <a:lnRef idx="1">
-            <a:schemeClr val="accent1"/>
-          </a:lnRef>
-          <a:fillRef idx="3">
-            <a:schemeClr val="accent1"/>
-          </a:fillRef>
-          <a:effectRef idx="2">
-            <a:schemeClr val="accent1"/>
-          </a:effectRef>
-          <a:fontRef idx="minor">
-            <a:schemeClr val="lt1"/>
-          </a:fontRef>
-        </p:style>
-        <p:txBody>
-          <a:bodyPr rtlCol="0" anchor="ctr"/>
-          <a:lstStyle/>
-          <a:p>
-            <a:pPr algn="ctr"/>
-          </a:p>
-        </p:txBody>
-      </p:sp>
-      <p:sp>
-        <p:nvSpPr>
-          <p:cNvPr id="8" name="TextBox 7"/>
-          <p:cNvSpPr txBox="1"/>
-          <p:nvPr/>
-        </p:nvSpPr>
-        <p:spPr>
-          <a:xfrm>
-            <a:off x="6400800" y="4114799"/>
-            <a:ext cx="4876495" cy="365760"/>
-          </a:xfrm>
-          <a:prstGeom prst="rect">
-            <a:avLst/>
-          </a:prstGeom>
-          <a:noFill/>
-        </p:spPr>
-        <p:txBody>
-          <a:bodyPr wrap="square" tIns="0" bIns="0" lIns="0" rIns="0">
-            <a:spAutoFit/>
-          </a:bodyPr>
-          <a:lstStyle/>
+                <a:latin typeface="Segoe UI"/>
+              </a:rPr>
+              <a:t>روابط مستخدمي المياه (WUAs) للمشاركة الفعالة عبر تطبيق الهاتف (Smart Farmer Drainage).</a:t>
+            </a:r>
+          </a:p>
           <a:p>
             <a:pPr algn="r">
-              <a:defRPr sz="1200" b="1">
-                <a:solidFill>
-                  <a:srgbClr val="F0C860"/>
-                </a:solidFill>
-              </a:defRPr>
-            </a:pPr>
-            <a:r>
-              <a:t>🛡️ 2. تحدي التلاعب الزراعي وابتكار الغرف غير المرئية</a:t>
-            </a:r>
-          </a:p>
-        </p:txBody>
-      </p:sp>
-      <p:sp>
-        <p:nvSpPr>
-          <p:cNvPr id="9" name="TextBox 8"/>
-          <p:cNvSpPr txBox="1"/>
-          <p:nvPr/>
-        </p:nvSpPr>
-        <p:spPr>
-          <a:xfrm>
-            <a:off x="6400800" y="4480559"/>
-            <a:ext cx="4876495" cy="1828800"/>
-          </a:xfrm>
-          <a:prstGeom prst="rect">
-            <a:avLst/>
-          </a:prstGeom>
-          <a:noFill/>
-        </p:spPr>
-        <p:txBody>
-          <a:bodyPr wrap="square" tIns="0" bIns="0" lIns="0" rIns="0">
-            <a:spAutoFit/>
-          </a:bodyPr>
-          <a:lstStyle/>
+              <a:lnSpc>
+                <a:spcPct val="125000"/>
+              </a:lnSpc>
+              <a:spcAft>
+                <a:spcPts val="600"/>
+              </a:spcAft>
+            </a:pPr>
+            <a:r>
+              <a:rPr sz="1150" b="1">
+                <a:solidFill>
+                  <a:srgbClr val="15B5A4"/>
+                </a:solidFill>
+                <a:latin typeface="Segoe UI"/>
+              </a:rPr>
+              <a:t>• هيكل الحوكمة متعدد المستويات: </a:t>
+            </a:r>
+            <a:r>
+              <a:rPr sz="1150">
+                <a:solidFill>
+                  <a:srgbClr val="F8FAFC"/>
+                </a:solidFill>
+                <a:latin typeface="Segoe UI"/>
+              </a:rPr>
+              <a:t>لجنة وزارية عليا توجيهية + وحدة إدارة مخصصة (PIU) بهيئة الصرف + لجان محلية بالمحافظات.</a:t>
+            </a:r>
+          </a:p>
           <a:p>
             <a:pPr algn="r">
-              <a:defRPr sz="950">
+              <a:lnSpc>
+                <a:spcPct val="125000"/>
+              </a:lnSpc>
+              <a:spcAft>
+                <a:spcPts val="0"/>
+              </a:spcAft>
+            </a:pPr>
+            <a:r>
+              <a:rPr sz="1150" b="1">
+                <a:solidFill>
+                  <a:srgbClr val="15B5A4"/>
+                </a:solidFill>
+                <a:latin typeface="Segoe UI"/>
+              </a:rPr>
+              <a:t>• التوافق الاستراتيجي الوطني: </a:t>
+            </a:r>
+            <a:r>
+              <a:rPr sz="1150">
                 <a:solidFill>
                   <a:srgbClr val="F8FAFC"/>
                 </a:solidFill>
-              </a:defRPr>
-            </a:pPr>
-            <a:r>
-              <a:t>• التعديات الزراعية العشوائية: سجلات هيئة الصرف (EPADP) توثق أن 25-40% من أعطال الصرف ناجمة عن سد المزارعين للمجمعات لحبس المياه للأرز.</a:t>
-            </a:r>
-          </a:p>
-          <a:p>
-            <a:pPr algn="r">
-              <a:defRPr sz="950">
-                <a:solidFill>
-                  <a:srgbClr val="F8FAFC"/>
-                </a:solidFill>
-              </a:defRPr>
-            </a:pPr>
-            <a:r>
-              <a:t>• ابتكار الغرف الغاطسة: استبدال الغرف السطحية بغرف مدفونة 30-50 سم تحت الأرض مع شرائح RFID ومواقع GPS للصيانة الرسمية فقط.</a:t>
-            </a:r>
-          </a:p>
-          <a:p>
-            <a:pPr algn="r">
-              <a:defRPr sz="950">
-                <a:solidFill>
-                  <a:srgbClr val="F8FAFC"/>
-                </a:solidFill>
-              </a:defRPr>
-            </a:pPr>
-            <a:r>
-              <a:t>• إنذار لحظي مشفر: حساسات MPU6050 ترصد أي اهتزاز أو حفر (&gt;2.5g) وتبث إنذار طوارئ GPS مشفر بـ AES-128 عبر NB-IoT إلى مركز التحكم.</a:t>
-            </a:r>
-          </a:p>
-        </p:txBody>
-      </p:sp>
-      <p:sp>
-        <p:nvSpPr>
-          <p:cNvPr id="10" name="Rounded Rectangle 9"/>
-          <p:cNvSpPr/>
-          <p:nvPr/>
-        </p:nvSpPr>
-        <p:spPr>
-          <a:xfrm>
-            <a:off x="731520" y="1463040"/>
-            <a:ext cx="5212080" cy="4937760"/>
-          </a:xfrm>
-          <a:prstGeom prst="roundRect">
-            <a:avLst/>
-          </a:prstGeom>
-          <a:solidFill>
-            <a:srgbClr val="0F2240"/>
-          </a:solidFill>
-          <a:ln w="12700">
-            <a:solidFill>
-              <a:srgbClr val="15B5A4"/>
-            </a:solidFill>
-          </a:ln>
-        </p:spPr>
-        <p:style>
-          <a:lnRef idx="1">
-            <a:schemeClr val="accent1"/>
-          </a:lnRef>
-          <a:fillRef idx="3">
-            <a:schemeClr val="accent1"/>
-          </a:fillRef>
-          <a:effectRef idx="2">
-            <a:schemeClr val="accent1"/>
-          </a:effectRef>
-          <a:fontRef idx="minor">
-            <a:schemeClr val="lt1"/>
-          </a:fontRef>
-        </p:style>
-        <p:txBody>
-          <a:bodyPr rtlCol="0" anchor="ctr"/>
-          <a:lstStyle/>
-          <a:p>
-            <a:pPr algn="ctr"/>
-          </a:p>
-        </p:txBody>
-      </p:sp>
-      <p:sp>
-        <p:nvSpPr>
-          <p:cNvPr id="11" name="TextBox 10"/>
-          <p:cNvSpPr txBox="1"/>
-          <p:nvPr/>
-        </p:nvSpPr>
-        <p:spPr>
-          <a:xfrm>
-            <a:off x="914400" y="1600200"/>
-            <a:ext cx="4846320" cy="365760"/>
-          </a:xfrm>
-          <a:prstGeom prst="rect">
-            <a:avLst/>
-          </a:prstGeom>
-          <a:noFill/>
-        </p:spPr>
-        <p:txBody>
-          <a:bodyPr wrap="square" tIns="0" bIns="0" lIns="0" rIns="0">
-            <a:spAutoFit/>
-          </a:bodyPr>
-          <a:lstStyle/>
-          <a:p>
-            <a:pPr algn="r">
-              <a:defRPr sz="1200" b="1">
-                <a:solidFill>
-                  <a:srgbClr val="15B5A4"/>
-                </a:solidFill>
-              </a:defRPr>
-            </a:pPr>
-            <a:r>
-              <a:t>🏛️ 3. الجهة القائدة، الشركاء وهيكل الحوكمة المؤسسية</a:t>
-            </a:r>
-          </a:p>
-        </p:txBody>
-      </p:sp>
-      <p:sp>
-        <p:nvSpPr>
-          <p:cNvPr id="12" name="TextBox 11"/>
-          <p:cNvSpPr txBox="1"/>
-          <p:nvPr/>
-        </p:nvSpPr>
-        <p:spPr>
-          <a:xfrm>
-            <a:off x="914400" y="1965960"/>
-            <a:ext cx="4846320" cy="4343400"/>
-          </a:xfrm>
-          <a:prstGeom prst="rect">
-            <a:avLst/>
-          </a:prstGeom>
-          <a:noFill/>
-        </p:spPr>
-        <p:txBody>
-          <a:bodyPr wrap="square" tIns="0" bIns="0" lIns="0" rIns="0">
-            <a:spAutoFit/>
-          </a:bodyPr>
-          <a:lstStyle/>
-          <a:p>
-            <a:pPr algn="r">
-              <a:defRPr sz="1000" b="1">
-                <a:solidFill>
-                  <a:srgbClr val="F0C860"/>
-                </a:solidFill>
-              </a:defRPr>
-            </a:pPr>
-            <a:r>
-              <a:t>• الجهة القائدة التنفيذية: وزارة الموارد المائية والري (MWRI) / الهيئة العامة لمشروعات الصرف (EPADP - المكتب الفني للوجه البحري).</a:t>
-            </a:r>
-          </a:p>
-          <a:p>
-            <a:pPr algn="r">
-              <a:defRPr sz="900">
-                <a:solidFill>
-                  <a:srgbClr val="F8FAFC"/>
-                </a:solidFill>
-              </a:defRPr>
-            </a:pPr>
-            <a:r>
-              <a:t>• الشركاء الفنيون والزراعيون: معهد بحوث الصرف (DRI) للمواصفات والتحقق المستقل، ووزارة الزراعة (MALR) لتحسين المحاصيل والإرشاد.</a:t>
-            </a:r>
-          </a:p>
-          <a:p>
-            <a:pPr algn="r">
-              <a:defRPr sz="900">
-                <a:solidFill>
-                  <a:srgbClr val="F8FAFC"/>
-                </a:solidFill>
-              </a:defRPr>
-            </a:pPr>
-            <a:r>
-              <a:t>• شريك الطاقة والربط الشبكي: هيئة الطاقة المتجددة (NREA) وجهاز تنظيم الكهرباء (EgyptERA) لتطبيق صافي القياس (Net Metering).</a:t>
-            </a:r>
-          </a:p>
-          <a:p>
-            <a:pPr algn="r">
-              <a:defRPr sz="900">
-                <a:solidFill>
-                  <a:srgbClr val="F8FAFC"/>
-                </a:solidFill>
-              </a:defRPr>
-            </a:pPr>
-            <a:r>
-              <a:t>• الحوكمة المجتمعية والميدانية: روابط مستخدمي المياه (WUAs) للمشاركة في إدارة المياه عبر تطبيق المحمول (Smart Farmer Drainage).</a:t>
-            </a:r>
-          </a:p>
-          <a:p>
-            <a:pPr algn="r">
-              <a:defRPr sz="900">
-                <a:solidFill>
-                  <a:srgbClr val="F8FAFC"/>
-                </a:solidFill>
-              </a:defRPr>
-            </a:pPr>
-            <a:r>
-              <a:t>• هيكل الحوكمة متعدد المستويات: • لجنة وزارية توجيهية عليا (الري، الزراعة، البيئة، المالية).</a:t>
-            </a:r>
-            <a:br/>
-            <a:r>
-              <a:t>• وحدة مخصصة لإدارة المشروع (PIU) داخل هيئة الصرف.</a:t>
-            </a:r>
-            <a:br/>
-            <a:r>
-              <a:t>• لجان محلية بالمحافظات لروابط المزارعين في كفر الشيخ والدقهلية.</a:t>
-            </a:r>
-          </a:p>
-          <a:p>
-            <a:pPr algn="r">
-              <a:defRPr sz="900">
-                <a:solidFill>
-                  <a:srgbClr val="F8FAFC"/>
-                </a:solidFill>
-              </a:defRPr>
-            </a:pPr>
-            <a:r>
-              <a:t>• التوافق الاستراتيجي الوطني: متوافق تماماً مع مبادرة 'منظومة المياه والري 2.0'، ورؤية مصر 2030، واستراتيجية تغير المناخ 2050.</a:t>
+                <a:latin typeface="Segoe UI"/>
+              </a:rPr>
+              <a:t>متوافق تماماً مع مبادرة 'منظومة المياه والري 2.0'، ورؤية مصر 2030، واستراتيجية المناخ 2050.</a:t>
             </a:r>
           </a:p>
         </p:txBody>
@@ -3716,14 +4178,116 @@
       </p:sp>
       <p:sp>
         <p:nvSpPr>
-          <p:cNvPr id="3" name="TextBox 2"/>
+          <p:cNvPr id="3" name="Rounded Rectangle 2"/>
+          <p:cNvSpPr/>
+          <p:nvPr/>
+        </p:nvSpPr>
+        <p:spPr>
+          <a:xfrm>
+            <a:off x="731520" y="146304"/>
+            <a:ext cx="10728655" cy="36576"/>
+          </a:xfrm>
+          <a:prstGeom prst="roundRect">
+            <a:avLst>
+              <a:gd name="adj" fmla="val 50000"/>
+            </a:avLst>
+          </a:prstGeom>
+          <a:solidFill>
+            <a:srgbClr val="15B5A4"/>
+          </a:solidFill>
+          <a:ln>
+            <a:noFill/>
+          </a:ln>
+        </p:spPr>
+        <p:style>
+          <a:lnRef idx="1">
+            <a:schemeClr val="accent1"/>
+          </a:lnRef>
+          <a:fillRef idx="3">
+            <a:schemeClr val="accent1"/>
+          </a:fillRef>
+          <a:effectRef idx="2">
+            <a:schemeClr val="accent1"/>
+          </a:effectRef>
+          <a:fontRef idx="minor">
+            <a:schemeClr val="lt1"/>
+          </a:fontRef>
+        </p:style>
+        <p:txBody>
+          <a:bodyPr rtlCol="0" anchor="ctr"/>
+          <a:lstStyle/>
+          <a:p>
+            <a:pPr algn="ctr"/>
+          </a:p>
+        </p:txBody>
+      </p:sp>
+      <p:sp>
+        <p:nvSpPr>
+          <p:cNvPr id="4" name="Rounded Rectangle 3"/>
+          <p:cNvSpPr/>
+          <p:nvPr/>
+        </p:nvSpPr>
+        <p:spPr>
+          <a:xfrm>
+            <a:off x="7253935" y="292608"/>
+            <a:ext cx="4206240" cy="292608"/>
+          </a:xfrm>
+          <a:prstGeom prst="roundRect">
+            <a:avLst>
+              <a:gd name="adj" fmla="val 50000"/>
+            </a:avLst>
+          </a:prstGeom>
+          <a:solidFill>
+            <a:srgbClr val="162D52"/>
+          </a:solidFill>
+          <a:ln w="15240">
+            <a:solidFill>
+              <a:srgbClr val="15B5A4"/>
+            </a:solidFill>
+          </a:ln>
+        </p:spPr>
+        <p:style>
+          <a:lnRef idx="1">
+            <a:schemeClr val="accent1"/>
+          </a:lnRef>
+          <a:fillRef idx="3">
+            <a:schemeClr val="accent1"/>
+          </a:fillRef>
+          <a:effectRef idx="2">
+            <a:schemeClr val="accent1"/>
+          </a:effectRef>
+          <a:fontRef idx="minor">
+            <a:schemeClr val="lt1"/>
+          </a:fontRef>
+        </p:style>
+        <p:txBody>
+          <a:bodyPr rtlCol="0" anchor="ctr" wrap="none" tIns="0" bIns="0" lIns="0" rIns="0"/>
+          <a:lstStyle/>
+          <a:p>
+            <a:pPr algn="ctr">
+              <a:defRPr sz="1050" b="1">
+                <a:solidFill>
+                  <a:srgbClr val="15B5A4"/>
+                </a:solidFill>
+                <a:latin typeface="Segoe UI"/>
+              </a:defRPr>
+            </a:pPr>
+            <a:r>
+              <a:t>الشريحة 2 من 3 | عرض تنفيذي في 5 دقائق | محور WEFE المقاوم للمناخ</a:t>
+            </a:r>
+          </a:p>
+        </p:txBody>
+      </p:sp>
+      <p:sp>
+        <p:nvSpPr>
+          <p:cNvPr id="5" name="TextBox 4"/>
           <p:cNvSpPr txBox="1"/>
           <p:nvPr/>
         </p:nvSpPr>
         <p:spPr>
           <a:xfrm>
-            <a:off x="731520" y="365760"/>
-            <a:ext cx="10728655" cy="1051560"/>
+            <a:off x="731520" y="658368"/>
+            <a:ext cx="10728655" cy="804672"/>
           </a:xfrm>
           <a:prstGeom prst="rect">
             <a:avLst/>
@@ -3737,58 +4301,796 @@
           <a:lstStyle/>
           <a:p>
             <a:pPr algn="r">
-              <a:defRPr sz="950" b="1">
-                <a:solidFill>
-                  <a:srgbClr val="15B5A4"/>
-                </a:solidFill>
+              <a:lnSpc>
+                <a:spcPct val="115000"/>
+              </a:lnSpc>
+              <a:defRPr sz="2200" b="1">
+                <a:solidFill>
+                  <a:srgbClr val="F8FAFC"/>
+                </a:solidFill>
+                <a:latin typeface="Segoe UI"/>
               </a:defRPr>
             </a:pPr>
             <a:r>
-              <a:t>الشريحة 2 من 3 | عرض تنفيذي في 5 دقائق | برنامج تمويل المرونة ومحور WEFE</a:t>
+              <a:t>تدخلات WEFE المتكاملة، مصفوفة الفرز الرسمية، وتعزيز الجدوى البنكية</a:t>
             </a:r>
           </a:p>
           <a:p>
             <a:pPr algn="r">
-              <a:defRPr sz="1900" b="1">
-                <a:solidFill>
-                  <a:srgbClr val="F8FAFC"/>
-                </a:solidFill>
+              <a:lnSpc>
+                <a:spcPct val="120000"/>
+              </a:lnSpc>
+              <a:defRPr sz="1200">
+                <a:solidFill>
+                  <a:srgbClr val="F0C860"/>
+                </a:solidFill>
+                <a:latin typeface="Segoe UI"/>
               </a:defRPr>
             </a:pPr>
             <a:r>
-              <a:t>تدخلات WEFE المتكاملة، مصفوفة الفرز الرسمية، وتعزيز الجدوى البنكية</a:t>
-            </a:r>
-          </a:p>
-          <a:p>
-            <a:pPr algn="r">
-              <a:defRPr sz="1100">
-                <a:solidFill>
-                  <a:srgbClr val="F0C860"/>
-                </a:solidFill>
-              </a:defRPr>
-            </a:pPr>
-            <a:r>
-              <a:t>2. التدخلات الرئيسية ومنافع WEFE المغلقة | تصحيحات التقرير: مصفوفة الفرز، النظم البيئية وتعزيز التمويل</a:t>
-            </a:r>
-          </a:p>
-        </p:txBody>
-      </p:sp>
-      <p:sp>
-        <p:nvSpPr>
-          <p:cNvPr id="4" name="Rounded Rectangle 3"/>
+              <a:t>2. التدخلات المغلقة الأربعة | تصحيحات التقرير: مصفوفة الفرز، النظم البيئية، وتعزيز الجدوى البنكية</a:t>
+            </a:r>
+          </a:p>
+        </p:txBody>
+      </p:sp>
+      <p:sp>
+        <p:nvSpPr>
+          <p:cNvPr id="6" name="Rounded Rectangle 5"/>
           <p:cNvSpPr/>
           <p:nvPr/>
         </p:nvSpPr>
         <p:spPr>
           <a:xfrm>
-            <a:off x="731520" y="1463040"/>
-            <a:ext cx="10728655" cy="2468880"/>
+            <a:off x="731520" y="1536192"/>
+            <a:ext cx="2532888" cy="2395728"/>
           </a:xfrm>
           <a:prstGeom prst="roundRect">
-            <a:avLst/>
+            <a:avLst>
+              <a:gd name="adj" fmla="val 9000"/>
+            </a:avLst>
           </a:prstGeom>
           <a:solidFill>
             <a:srgbClr val="0F2240"/>
+          </a:solidFill>
+          <a:ln w="15240">
+            <a:solidFill>
+              <a:srgbClr val="3B82F6"/>
+            </a:solidFill>
+          </a:ln>
+        </p:spPr>
+        <p:style>
+          <a:lnRef idx="1">
+            <a:schemeClr val="accent1"/>
+          </a:lnRef>
+          <a:fillRef idx="3">
+            <a:schemeClr val="accent1"/>
+          </a:fillRef>
+          <a:effectRef idx="2">
+            <a:schemeClr val="accent1"/>
+          </a:effectRef>
+          <a:fontRef idx="minor">
+            <a:schemeClr val="lt1"/>
+          </a:fontRef>
+        </p:style>
+        <p:txBody>
+          <a:bodyPr rtlCol="0" anchor="ctr"/>
+          <a:lstStyle/>
+          <a:p>
+            <a:pPr algn="ctr"/>
+          </a:p>
+        </p:txBody>
+      </p:sp>
+      <p:sp>
+        <p:nvSpPr>
+          <p:cNvPr id="7" name="TextBox 6"/>
+          <p:cNvSpPr txBox="1"/>
+          <p:nvPr/>
+        </p:nvSpPr>
+        <p:spPr>
+          <a:xfrm>
+            <a:off x="932688" y="1645920"/>
+            <a:ext cx="2130552" cy="347472"/>
+          </a:xfrm>
+          <a:prstGeom prst="rect">
+            <a:avLst/>
+          </a:prstGeom>
+          <a:noFill/>
+        </p:spPr>
+        <p:txBody>
+          <a:bodyPr wrap="square" tIns="0" bIns="0" lIns="0" rIns="0">
+            <a:spAutoFit/>
+          </a:bodyPr>
+          <a:lstStyle/>
+          <a:p>
+            <a:pPr algn="r">
+              <a:defRPr sz="1450" b="1">
+                <a:solidFill>
+                  <a:srgbClr val="3B82F6"/>
+                </a:solidFill>
+                <a:latin typeface="Segoe UI"/>
+              </a:defRPr>
+            </a:pPr>
+            <a:r>
+              <a:t>💧 المياه (Water)</a:t>
+            </a:r>
+          </a:p>
+        </p:txBody>
+      </p:sp>
+      <p:sp>
+        <p:nvSpPr>
+          <p:cNvPr id="8" name="Rounded Rectangle 7"/>
+          <p:cNvSpPr/>
+          <p:nvPr/>
+        </p:nvSpPr>
+        <p:spPr>
+          <a:xfrm>
+            <a:off x="914400" y="1975104"/>
+            <a:ext cx="2167128" cy="310896"/>
+          </a:xfrm>
+          <a:prstGeom prst="roundRect">
+            <a:avLst>
+              <a:gd name="adj" fmla="val 35000"/>
+            </a:avLst>
+          </a:prstGeom>
+          <a:solidFill>
+            <a:srgbClr val="162D52"/>
+          </a:solidFill>
+          <a:ln w="12700">
+            <a:solidFill>
+              <a:srgbClr val="3B82F6"/>
+            </a:solidFill>
+          </a:ln>
+        </p:spPr>
+        <p:style>
+          <a:lnRef idx="1">
+            <a:schemeClr val="accent1"/>
+          </a:lnRef>
+          <a:fillRef idx="3">
+            <a:schemeClr val="accent1"/>
+          </a:fillRef>
+          <a:effectRef idx="2">
+            <a:schemeClr val="accent1"/>
+          </a:effectRef>
+          <a:fontRef idx="minor">
+            <a:schemeClr val="lt1"/>
+          </a:fontRef>
+        </p:style>
+        <p:txBody>
+          <a:bodyPr rtlCol="0" anchor="ctr" wrap="square" tIns="0" bIns="0" lIns="0" rIns="0"/>
+          <a:lstStyle/>
+          <a:p>
+            <a:pPr algn="r">
+              <a:defRPr sz="1150" b="1">
+                <a:solidFill>
+                  <a:srgbClr val="F0C860"/>
+                </a:solidFill>
+                <a:latin typeface="Segoe UI"/>
+              </a:defRPr>
+            </a:pPr>
+            <a:r>
+              <a:t> وفر 150M م³/سنة (25-30%) </a:t>
+            </a:r>
+          </a:p>
+        </p:txBody>
+      </p:sp>
+      <p:sp>
+        <p:nvSpPr>
+          <p:cNvPr id="9" name="TextBox 8"/>
+          <p:cNvSpPr txBox="1"/>
+          <p:nvPr/>
+        </p:nvSpPr>
+        <p:spPr>
+          <a:xfrm>
+            <a:off x="932688" y="2340864"/>
+            <a:ext cx="2130552" cy="1499616"/>
+          </a:xfrm>
+          <a:prstGeom prst="rect">
+            <a:avLst/>
+          </a:prstGeom>
+          <a:noFill/>
+        </p:spPr>
+        <p:txBody>
+          <a:bodyPr wrap="square" tIns="0" bIns="0" lIns="0" rIns="0">
+            <a:spAutoFit/>
+          </a:bodyPr>
+          <a:lstStyle/>
+          <a:p>
+            <a:pPr algn="r">
+              <a:lnSpc>
+                <a:spcPct val="125000"/>
+              </a:lnSpc>
+              <a:spcAft>
+                <a:spcPts val="500"/>
+              </a:spcAft>
+            </a:pPr>
+            <a:r>
+              <a:rPr sz="1100" b="1">
+                <a:solidFill>
+                  <a:srgbClr val="3B82F6"/>
+                </a:solidFill>
+                <a:latin typeface="Segoe UI"/>
+              </a:rPr>
+              <a:t>• التقنية: </a:t>
+            </a:r>
+            <a:r>
+              <a:rPr sz="1100">
+                <a:solidFill>
+                  <a:srgbClr val="F8FAFC"/>
+                </a:solidFill>
+                <a:latin typeface="Segoe UI"/>
+              </a:rPr>
+              <a:t>إحلال 100k فدان بمواسير HDPE وفلاتر جيوتكستيل (عمر 40+ سنة).</a:t>
+            </a:r>
+          </a:p>
+          <a:p>
+            <a:pPr algn="r">
+              <a:lnSpc>
+                <a:spcPct val="125000"/>
+              </a:lnSpc>
+              <a:spcAft>
+                <a:spcPts val="0"/>
+              </a:spcAft>
+            </a:pPr>
+            <a:r>
+              <a:rPr sz="1100" b="1">
+                <a:solidFill>
+                  <a:srgbClr val="3B82F6"/>
+                </a:solidFill>
+                <a:latin typeface="Segoe UI"/>
+              </a:rPr>
+              <a:t>• التحكم: </a:t>
+            </a:r>
+            <a:r>
+              <a:rPr sz="1100">
+                <a:solidFill>
+                  <a:srgbClr val="F8FAFC"/>
+                </a:solidFill>
+                <a:latin typeface="Segoe UI"/>
+              </a:rPr>
+              <a:t>صمامات ذكية تستفيد من الصعود الشعري لتغذية جذور المحاصيل ذاتياً.</a:t>
+            </a:r>
+          </a:p>
+        </p:txBody>
+      </p:sp>
+      <p:sp>
+        <p:nvSpPr>
+          <p:cNvPr id="10" name="Rounded Rectangle 9"/>
+          <p:cNvSpPr/>
+          <p:nvPr/>
+        </p:nvSpPr>
+        <p:spPr>
+          <a:xfrm>
+            <a:off x="3456432" y="1536192"/>
+            <a:ext cx="2532888" cy="2395728"/>
+          </a:xfrm>
+          <a:prstGeom prst="roundRect">
+            <a:avLst>
+              <a:gd name="adj" fmla="val 9000"/>
+            </a:avLst>
+          </a:prstGeom>
+          <a:solidFill>
+            <a:srgbClr val="0F2240"/>
+          </a:solidFill>
+          <a:ln w="15240">
+            <a:solidFill>
+              <a:srgbClr val="F0C860"/>
+            </a:solidFill>
+          </a:ln>
+        </p:spPr>
+        <p:style>
+          <a:lnRef idx="1">
+            <a:schemeClr val="accent1"/>
+          </a:lnRef>
+          <a:fillRef idx="3">
+            <a:schemeClr val="accent1"/>
+          </a:fillRef>
+          <a:effectRef idx="2">
+            <a:schemeClr val="accent1"/>
+          </a:effectRef>
+          <a:fontRef idx="minor">
+            <a:schemeClr val="lt1"/>
+          </a:fontRef>
+        </p:style>
+        <p:txBody>
+          <a:bodyPr rtlCol="0" anchor="ctr"/>
+          <a:lstStyle/>
+          <a:p>
+            <a:pPr algn="ctr"/>
+          </a:p>
+        </p:txBody>
+      </p:sp>
+      <p:sp>
+        <p:nvSpPr>
+          <p:cNvPr id="11" name="TextBox 10"/>
+          <p:cNvSpPr txBox="1"/>
+          <p:nvPr/>
+        </p:nvSpPr>
+        <p:spPr>
+          <a:xfrm>
+            <a:off x="3657600" y="1645920"/>
+            <a:ext cx="2130552" cy="347472"/>
+          </a:xfrm>
+          <a:prstGeom prst="rect">
+            <a:avLst/>
+          </a:prstGeom>
+          <a:noFill/>
+        </p:spPr>
+        <p:txBody>
+          <a:bodyPr wrap="square" tIns="0" bIns="0" lIns="0" rIns="0">
+            <a:spAutoFit/>
+          </a:bodyPr>
+          <a:lstStyle/>
+          <a:p>
+            <a:pPr algn="r">
+              <a:defRPr sz="1450" b="1">
+                <a:solidFill>
+                  <a:srgbClr val="F0C860"/>
+                </a:solidFill>
+                <a:latin typeface="Segoe UI"/>
+              </a:defRPr>
+            </a:pPr>
+            <a:r>
+              <a:t>☀️ الطاقة (Energy)</a:t>
+            </a:r>
+          </a:p>
+        </p:txBody>
+      </p:sp>
+      <p:sp>
+        <p:nvSpPr>
+          <p:cNvPr id="12" name="Rounded Rectangle 11"/>
+          <p:cNvSpPr/>
+          <p:nvPr/>
+        </p:nvSpPr>
+        <p:spPr>
+          <a:xfrm>
+            <a:off x="3639312" y="1975104"/>
+            <a:ext cx="2167128" cy="310896"/>
+          </a:xfrm>
+          <a:prstGeom prst="roundRect">
+            <a:avLst>
+              <a:gd name="adj" fmla="val 35000"/>
+            </a:avLst>
+          </a:prstGeom>
+          <a:solidFill>
+            <a:srgbClr val="162D52"/>
+          </a:solidFill>
+          <a:ln w="12700">
+            <a:solidFill>
+              <a:srgbClr val="F0C860"/>
+            </a:solidFill>
+          </a:ln>
+        </p:spPr>
+        <p:style>
+          <a:lnRef idx="1">
+            <a:schemeClr val="accent1"/>
+          </a:lnRef>
+          <a:fillRef idx="3">
+            <a:schemeClr val="accent1"/>
+          </a:fillRef>
+          <a:effectRef idx="2">
+            <a:schemeClr val="accent1"/>
+          </a:effectRef>
+          <a:fontRef idx="minor">
+            <a:schemeClr val="lt1"/>
+          </a:fontRef>
+        </p:style>
+        <p:txBody>
+          <a:bodyPr rtlCol="0" anchor="ctr" wrap="square" tIns="0" bIns="0" lIns="0" rIns="0"/>
+          <a:lstStyle/>
+          <a:p>
+            <a:pPr algn="r">
+              <a:defRPr sz="1150" b="1">
+                <a:solidFill>
+                  <a:srgbClr val="F0C860"/>
+                </a:solidFill>
+                <a:latin typeface="Segoe UI"/>
+              </a:defRPr>
+            </a:pPr>
+            <a:r>
+              <a:t> 50 MW شمسية | 90 GWh/سنة </a:t>
+            </a:r>
+          </a:p>
+        </p:txBody>
+      </p:sp>
+      <p:sp>
+        <p:nvSpPr>
+          <p:cNvPr id="13" name="TextBox 12"/>
+          <p:cNvSpPr txBox="1"/>
+          <p:nvPr/>
+        </p:nvSpPr>
+        <p:spPr>
+          <a:xfrm>
+            <a:off x="3657600" y="2340864"/>
+            <a:ext cx="2130552" cy="1499616"/>
+          </a:xfrm>
+          <a:prstGeom prst="rect">
+            <a:avLst/>
+          </a:prstGeom>
+          <a:noFill/>
+        </p:spPr>
+        <p:txBody>
+          <a:bodyPr wrap="square" tIns="0" bIns="0" lIns="0" rIns="0">
+            <a:spAutoFit/>
+          </a:bodyPr>
+          <a:lstStyle/>
+          <a:p>
+            <a:pPr algn="r">
+              <a:lnSpc>
+                <a:spcPct val="125000"/>
+              </a:lnSpc>
+              <a:spcAft>
+                <a:spcPts val="500"/>
+              </a:spcAft>
+            </a:pPr>
+            <a:r>
+              <a:rPr sz="1100" b="1">
+                <a:solidFill>
+                  <a:srgbClr val="F0C860"/>
+                </a:solidFill>
+                <a:latin typeface="Segoe UI"/>
+              </a:rPr>
+              <a:t>• المحطات: </a:t>
+            </a:r>
+            <a:r>
+              <a:rPr sz="1100">
+                <a:solidFill>
+                  <a:srgbClr val="F8FAFC"/>
+                </a:solidFill>
+                <a:latin typeface="Segoe UI"/>
+              </a:rPr>
+              <a:t>طاقة شمسية موزعة على 25 محطة رفع لتشغيل طلمبات الصرف.</a:t>
+            </a:r>
+          </a:p>
+          <a:p>
+            <a:pPr algn="r">
+              <a:lnSpc>
+                <a:spcPct val="125000"/>
+              </a:lnSpc>
+              <a:spcAft>
+                <a:spcPts val="0"/>
+              </a:spcAft>
+            </a:pPr>
+            <a:r>
+              <a:rPr sz="1100" b="1">
+                <a:solidFill>
+                  <a:srgbClr val="F0C860"/>
+                </a:solidFill>
+                <a:latin typeface="Segoe UI"/>
+              </a:rPr>
+              <a:t>• الوفر: </a:t>
+            </a:r>
+            <a:r>
+              <a:rPr sz="1100">
+                <a:solidFill>
+                  <a:srgbClr val="F8FAFC"/>
+                </a:solidFill>
+                <a:latin typeface="Segoe UI"/>
+              </a:rPr>
+              <a:t>خفض 40% من تكلفة الضخ وتصدير الفائض بنظام صافي القياس.</a:t>
+            </a:r>
+          </a:p>
+        </p:txBody>
+      </p:sp>
+      <p:sp>
+        <p:nvSpPr>
+          <p:cNvPr id="14" name="Rounded Rectangle 13"/>
+          <p:cNvSpPr/>
+          <p:nvPr/>
+        </p:nvSpPr>
+        <p:spPr>
+          <a:xfrm>
+            <a:off x="6181344" y="1536192"/>
+            <a:ext cx="2532888" cy="2395728"/>
+          </a:xfrm>
+          <a:prstGeom prst="roundRect">
+            <a:avLst>
+              <a:gd name="adj" fmla="val 9000"/>
+            </a:avLst>
+          </a:prstGeom>
+          <a:solidFill>
+            <a:srgbClr val="0F2240"/>
+          </a:solidFill>
+          <a:ln w="15240">
+            <a:solidFill>
+              <a:srgbClr val="10B981"/>
+            </a:solidFill>
+          </a:ln>
+        </p:spPr>
+        <p:style>
+          <a:lnRef idx="1">
+            <a:schemeClr val="accent1"/>
+          </a:lnRef>
+          <a:fillRef idx="3">
+            <a:schemeClr val="accent1"/>
+          </a:fillRef>
+          <a:effectRef idx="2">
+            <a:schemeClr val="accent1"/>
+          </a:effectRef>
+          <a:fontRef idx="minor">
+            <a:schemeClr val="lt1"/>
+          </a:fontRef>
+        </p:style>
+        <p:txBody>
+          <a:bodyPr rtlCol="0" anchor="ctr"/>
+          <a:lstStyle/>
+          <a:p>
+            <a:pPr algn="ctr"/>
+          </a:p>
+        </p:txBody>
+      </p:sp>
+      <p:sp>
+        <p:nvSpPr>
+          <p:cNvPr id="15" name="TextBox 14"/>
+          <p:cNvSpPr txBox="1"/>
+          <p:nvPr/>
+        </p:nvSpPr>
+        <p:spPr>
+          <a:xfrm>
+            <a:off x="6382512" y="1645920"/>
+            <a:ext cx="2130552" cy="347472"/>
+          </a:xfrm>
+          <a:prstGeom prst="rect">
+            <a:avLst/>
+          </a:prstGeom>
+          <a:noFill/>
+        </p:spPr>
+        <p:txBody>
+          <a:bodyPr wrap="square" tIns="0" bIns="0" lIns="0" rIns="0">
+            <a:spAutoFit/>
+          </a:bodyPr>
+          <a:lstStyle/>
+          <a:p>
+            <a:pPr algn="r">
+              <a:defRPr sz="1450" b="1">
+                <a:solidFill>
+                  <a:srgbClr val="10B981"/>
+                </a:solidFill>
+                <a:latin typeface="Segoe UI"/>
+              </a:defRPr>
+            </a:pPr>
+            <a:r>
+              <a:t>🌾 الغذاء (Food)</a:t>
+            </a:r>
+          </a:p>
+        </p:txBody>
+      </p:sp>
+      <p:sp>
+        <p:nvSpPr>
+          <p:cNvPr id="16" name="Rounded Rectangle 15"/>
+          <p:cNvSpPr/>
+          <p:nvPr/>
+        </p:nvSpPr>
+        <p:spPr>
+          <a:xfrm>
+            <a:off x="6364224" y="1975104"/>
+            <a:ext cx="2167128" cy="310896"/>
+          </a:xfrm>
+          <a:prstGeom prst="roundRect">
+            <a:avLst>
+              <a:gd name="adj" fmla="val 35000"/>
+            </a:avLst>
+          </a:prstGeom>
+          <a:solidFill>
+            <a:srgbClr val="162D52"/>
+          </a:solidFill>
+          <a:ln w="12700">
+            <a:solidFill>
+              <a:srgbClr val="10B981"/>
+            </a:solidFill>
+          </a:ln>
+        </p:spPr>
+        <p:style>
+          <a:lnRef idx="1">
+            <a:schemeClr val="accent1"/>
+          </a:lnRef>
+          <a:fillRef idx="3">
+            <a:schemeClr val="accent1"/>
+          </a:fillRef>
+          <a:effectRef idx="2">
+            <a:schemeClr val="accent1"/>
+          </a:effectRef>
+          <a:fontRef idx="minor">
+            <a:schemeClr val="lt1"/>
+          </a:fontRef>
+        </p:style>
+        <p:txBody>
+          <a:bodyPr rtlCol="0" anchor="ctr" wrap="square" tIns="0" bIns="0" lIns="0" rIns="0"/>
+          <a:lstStyle/>
+          <a:p>
+            <a:pPr algn="r">
+              <a:defRPr sz="1150" b="1">
+                <a:solidFill>
+                  <a:srgbClr val="F0C860"/>
+                </a:solidFill>
+                <a:latin typeface="Segoe UI"/>
+              </a:defRPr>
+            </a:pPr>
+            <a:r>
+              <a:t> +15-25% زيادة المحاصيل </a:t>
+            </a:r>
+          </a:p>
+        </p:txBody>
+      </p:sp>
+      <p:sp>
+        <p:nvSpPr>
+          <p:cNvPr id="17" name="TextBox 16"/>
+          <p:cNvSpPr txBox="1"/>
+          <p:nvPr/>
+        </p:nvSpPr>
+        <p:spPr>
+          <a:xfrm>
+            <a:off x="6382512" y="2340864"/>
+            <a:ext cx="2130552" cy="1499616"/>
+          </a:xfrm>
+          <a:prstGeom prst="rect">
+            <a:avLst/>
+          </a:prstGeom>
+          <a:noFill/>
+        </p:spPr>
+        <p:txBody>
+          <a:bodyPr wrap="square" tIns="0" bIns="0" lIns="0" rIns="0">
+            <a:spAutoFit/>
+          </a:bodyPr>
+          <a:lstStyle/>
+          <a:p>
+            <a:pPr algn="r">
+              <a:lnSpc>
+                <a:spcPct val="125000"/>
+              </a:lnSpc>
+              <a:spcAft>
+                <a:spcPts val="500"/>
+              </a:spcAft>
+            </a:pPr>
+            <a:r>
+              <a:rPr sz="1100" b="1">
+                <a:solidFill>
+                  <a:srgbClr val="10B981"/>
+                </a:solidFill>
+                <a:latin typeface="Segoe UI"/>
+              </a:rPr>
+              <a:t>• المحاصيل: </a:t>
+            </a:r>
+            <a:r>
+              <a:rPr sz="1100">
+                <a:solidFill>
+                  <a:srgbClr val="F8FAFC"/>
+                </a:solidFill>
+                <a:latin typeface="Segoe UI"/>
+              </a:rPr>
+              <a:t>زيادة غلة القمح والذرة والأرز لأكثر من 200,000 مزارع.</a:t>
+            </a:r>
+          </a:p>
+          <a:p>
+            <a:pPr algn="r">
+              <a:lnSpc>
+                <a:spcPct val="125000"/>
+              </a:lnSpc>
+              <a:spcAft>
+                <a:spcPts val="0"/>
+              </a:spcAft>
+            </a:pPr>
+            <a:r>
+              <a:rPr sz="1100" b="1">
+                <a:solidFill>
+                  <a:srgbClr val="10B981"/>
+                </a:solidFill>
+                <a:latin typeface="Segoe UI"/>
+              </a:rPr>
+              <a:t>• غسيل ذكي: </a:t>
+            </a:r>
+            <a:r>
+              <a:rPr sz="1100">
+                <a:solidFill>
+                  <a:srgbClr val="F8FAFC"/>
+                </a:solidFill>
+                <a:latin typeface="Segoe UI"/>
+              </a:rPr>
+              <a:t>صمام آلي يفتح للغسيل عند EC &gt; 4 ويغلق عند EC &lt; 2 dS/m.</a:t>
+            </a:r>
+          </a:p>
+        </p:txBody>
+      </p:sp>
+      <p:sp>
+        <p:nvSpPr>
+          <p:cNvPr id="18" name="Rounded Rectangle 17"/>
+          <p:cNvSpPr/>
+          <p:nvPr/>
+        </p:nvSpPr>
+        <p:spPr>
+          <a:xfrm>
+            <a:off x="8906256" y="1536192"/>
+            <a:ext cx="2532888" cy="2395728"/>
+          </a:xfrm>
+          <a:prstGeom prst="roundRect">
+            <a:avLst>
+              <a:gd name="adj" fmla="val 9000"/>
+            </a:avLst>
+          </a:prstGeom>
+          <a:solidFill>
+            <a:srgbClr val="0F2240"/>
+          </a:solidFill>
+          <a:ln w="15240">
+            <a:solidFill>
+              <a:srgbClr val="15B5A4"/>
+            </a:solidFill>
+          </a:ln>
+        </p:spPr>
+        <p:style>
+          <a:lnRef idx="1">
+            <a:schemeClr val="accent1"/>
+          </a:lnRef>
+          <a:fillRef idx="3">
+            <a:schemeClr val="accent1"/>
+          </a:fillRef>
+          <a:effectRef idx="2">
+            <a:schemeClr val="accent1"/>
+          </a:effectRef>
+          <a:fontRef idx="minor">
+            <a:schemeClr val="lt1"/>
+          </a:fontRef>
+        </p:style>
+        <p:txBody>
+          <a:bodyPr rtlCol="0" anchor="ctr"/>
+          <a:lstStyle/>
+          <a:p>
+            <a:pPr algn="ctr"/>
+          </a:p>
+        </p:txBody>
+      </p:sp>
+      <p:sp>
+        <p:nvSpPr>
+          <p:cNvPr id="19" name="TextBox 18"/>
+          <p:cNvSpPr txBox="1"/>
+          <p:nvPr/>
+        </p:nvSpPr>
+        <p:spPr>
+          <a:xfrm>
+            <a:off x="9107424" y="1645920"/>
+            <a:ext cx="2130552" cy="347472"/>
+          </a:xfrm>
+          <a:prstGeom prst="rect">
+            <a:avLst/>
+          </a:prstGeom>
+          <a:noFill/>
+        </p:spPr>
+        <p:txBody>
+          <a:bodyPr wrap="square" tIns="0" bIns="0" lIns="0" rIns="0">
+            <a:spAutoFit/>
+          </a:bodyPr>
+          <a:lstStyle/>
+          <a:p>
+            <a:pPr algn="r">
+              <a:defRPr sz="1450" b="1">
+                <a:solidFill>
+                  <a:srgbClr val="15B5A4"/>
+                </a:solidFill>
+                <a:latin typeface="Segoe UI"/>
+              </a:defRPr>
+            </a:pPr>
+            <a:r>
+              <a:t>🌿 النظم البيئية</a:t>
+            </a:r>
+          </a:p>
+        </p:txBody>
+      </p:sp>
+      <p:sp>
+        <p:nvSpPr>
+          <p:cNvPr id="20" name="Rounded Rectangle 19"/>
+          <p:cNvSpPr/>
+          <p:nvPr/>
+        </p:nvSpPr>
+        <p:spPr>
+          <a:xfrm>
+            <a:off x="9089136" y="1975104"/>
+            <a:ext cx="2167128" cy="310896"/>
+          </a:xfrm>
+          <a:prstGeom prst="roundRect">
+            <a:avLst>
+              <a:gd name="adj" fmla="val 35000"/>
+            </a:avLst>
+          </a:prstGeom>
+          <a:solidFill>
+            <a:srgbClr val="162D52"/>
           </a:solidFill>
           <a:ln w="12700">
             <a:solidFill>
@@ -3811,23 +5113,33 @@
           </a:fontRef>
         </p:style>
         <p:txBody>
-          <a:bodyPr rtlCol="0" anchor="ctr"/>
-          <a:lstStyle/>
-          <a:p>
-            <a:pPr algn="ctr"/>
-          </a:p>
-        </p:txBody>
-      </p:sp>
-      <p:sp>
-        <p:nvSpPr>
-          <p:cNvPr id="5" name="TextBox 4"/>
+          <a:bodyPr rtlCol="0" anchor="ctr" wrap="square" tIns="0" bIns="0" lIns="0" rIns="0"/>
+          <a:lstStyle/>
+          <a:p>
+            <a:pPr algn="r">
+              <a:defRPr sz="1150" b="1">
+                <a:solidFill>
+                  <a:srgbClr val="F0C860"/>
+                </a:solidFill>
+                <a:latin typeface="Segoe UI"/>
+              </a:defRPr>
+            </a:pPr>
+            <a:r>
+              <a:t> 100k طن كربون | 4,760 فدان </a:t>
+            </a:r>
+          </a:p>
+        </p:txBody>
+      </p:sp>
+      <p:sp>
+        <p:nvSpPr>
+          <p:cNvPr id="21" name="TextBox 20"/>
           <p:cNvSpPr txBox="1"/>
           <p:nvPr/>
         </p:nvSpPr>
         <p:spPr>
           <a:xfrm>
-            <a:off x="914400" y="1600200"/>
-            <a:ext cx="10362895" cy="365760"/>
+            <a:off x="9107424" y="2340864"/>
+            <a:ext cx="2130552" cy="1499616"/>
           </a:xfrm>
           <a:prstGeom prst="rect">
             <a:avLst/>
@@ -3841,28 +5153,119 @@
           <a:lstStyle/>
           <a:p>
             <a:pPr algn="r">
-              <a:defRPr sz="1200" b="1">
-                <a:solidFill>
-                  <a:srgbClr val="F0C860"/>
-                </a:solidFill>
-              </a:defRPr>
-            </a:pPr>
-            <a:r>
-              <a:t>⚡ 1. التدخلات الأربعة المغلقة لمحور WEFE (المشروع التجريبي 100,000 فدان)</a:t>
-            </a:r>
-          </a:p>
-        </p:txBody>
-      </p:sp>
-      <p:sp>
-        <p:nvSpPr>
-          <p:cNvPr id="6" name="TextBox 5"/>
+              <a:lnSpc>
+                <a:spcPct val="125000"/>
+              </a:lnSpc>
+              <a:spcAft>
+                <a:spcPts val="500"/>
+              </a:spcAft>
+            </a:pPr>
+            <a:r>
+              <a:rPr sz="1100" b="1">
+                <a:solidFill>
+                  <a:srgbClr val="15B5A4"/>
+                </a:solidFill>
+                <a:latin typeface="Segoe UI"/>
+              </a:rPr>
+              <a:t>• أراضٍ رطبة: </a:t>
+            </a:r>
+            <a:r>
+              <a:rPr sz="1100">
+                <a:solidFill>
+                  <a:srgbClr val="F8FAFC"/>
+                </a:solidFill>
+                <a:latin typeface="Segoe UI"/>
+              </a:rPr>
+              <a:t>20 محطة معالجة طبيعية تنقي 200M م³ مياه صرف حيوياً.</a:t>
+            </a:r>
+          </a:p>
+          <a:p>
+            <a:pPr algn="r">
+              <a:lnSpc>
+                <a:spcPct val="125000"/>
+              </a:lnSpc>
+              <a:spcAft>
+                <a:spcPts val="0"/>
+              </a:spcAft>
+            </a:pPr>
+            <a:r>
+              <a:rPr sz="1100" b="1">
+                <a:solidFill>
+                  <a:srgbClr val="15B5A4"/>
+                </a:solidFill>
+                <a:latin typeface="Segoe UI"/>
+              </a:rPr>
+              <a:t>• الأثر البيئي: </a:t>
+            </a:r>
+            <a:r>
+              <a:rPr sz="1100">
+                <a:solidFill>
+                  <a:srgbClr val="F8FAFC"/>
+                </a:solidFill>
+                <a:latin typeface="Segoe UI"/>
+              </a:rPr>
+              <a:t>حماية بحيرات الدلتا الشمالية والتنوع البيولوجي للأسماك.</a:t>
+            </a:r>
+          </a:p>
+        </p:txBody>
+      </p:sp>
+      <p:sp>
+        <p:nvSpPr>
+          <p:cNvPr id="22" name="Rounded Rectangle 21"/>
+          <p:cNvSpPr/>
+          <p:nvPr/>
+        </p:nvSpPr>
+        <p:spPr>
+          <a:xfrm>
+            <a:off x="6217920" y="4069080"/>
+            <a:ext cx="5242255" cy="2423160"/>
+          </a:xfrm>
+          <a:prstGeom prst="roundRect">
+            <a:avLst>
+              <a:gd name="adj" fmla="val 8000"/>
+            </a:avLst>
+          </a:prstGeom>
+          <a:solidFill>
+            <a:srgbClr val="0F2240"/>
+          </a:solidFill>
+          <a:ln w="16510">
+            <a:solidFill>
+              <a:srgbClr val="15B5A4"/>
+            </a:solidFill>
+          </a:ln>
+        </p:spPr>
+        <p:style>
+          <a:lnRef idx="1">
+            <a:schemeClr val="accent1"/>
+          </a:lnRef>
+          <a:fillRef idx="3">
+            <a:schemeClr val="accent1"/>
+          </a:fillRef>
+          <a:effectRef idx="2">
+            <a:schemeClr val="accent1"/>
+          </a:effectRef>
+          <a:fontRef idx="minor">
+            <a:schemeClr val="lt1"/>
+          </a:fontRef>
+        </p:style>
+        <p:txBody>
+          <a:bodyPr rtlCol="0" anchor="ctr"/>
+          <a:lstStyle/>
+          <a:p>
+            <a:pPr algn="ctr"/>
+          </a:p>
+        </p:txBody>
+      </p:sp>
+      <p:sp>
+        <p:nvSpPr>
+          <p:cNvPr id="23" name="TextBox 22"/>
           <p:cNvSpPr txBox="1"/>
           <p:nvPr/>
         </p:nvSpPr>
         <p:spPr>
           <a:xfrm>
-            <a:off x="914400" y="1965960"/>
-            <a:ext cx="10362895" cy="1874520"/>
+            <a:off x="6419088" y="4178808"/>
+            <a:ext cx="4839919" cy="347472"/>
           </a:xfrm>
           <a:prstGeom prst="rect">
             <a:avLst/>
@@ -3876,70 +5279,37 @@
           <a:lstStyle/>
           <a:p>
             <a:pPr algn="r">
-              <a:defRPr sz="950">
-                <a:solidFill>
-                  <a:srgbClr val="F8FAFC"/>
-                </a:solidFill>
+              <a:defRPr sz="1450" b="1">
+                <a:solidFill>
+                  <a:srgbClr val="15B5A4"/>
+                </a:solidFill>
+                <a:latin typeface="Segoe UI"/>
               </a:defRPr>
             </a:pPr>
             <a:r>
-              <a:t>💧 المياه (Water): إحلال 100 ألف فدان بمواسير HDPE وفلاتر جيوتكستيل (40+ سنة عمر). صمامات كهربائية تتحكم بالصعود الشعري (h=2γcosθ/ρgr) لتوفير 150M م³/سنة مياه ري (25-30%).</a:t>
-            </a:r>
-          </a:p>
-          <a:p>
-            <a:pPr algn="r">
-              <a:defRPr sz="950">
-                <a:solidFill>
-                  <a:srgbClr val="F8FAFC"/>
-                </a:solidFill>
-              </a:defRPr>
-            </a:pPr>
-            <a:r>
-              <a:t>☀️ الطاقة (Energy): محطات شمسية 50 MW موزعة على 25 محطة رفع تولد 90 GWh/سنة وتخفض فاتورة الكهرباء 40% مع تصدير الفائض للشبكة القومية بنظام صافي القياس.</a:t>
-            </a:r>
-          </a:p>
-          <a:p>
-            <a:pPr algn="r">
-              <a:defRPr sz="950">
-                <a:solidFill>
-                  <a:srgbClr val="F8FAFC"/>
-                </a:solidFill>
-              </a:defRPr>
-            </a:pPr>
-            <a:r>
-              <a:t>🌾 الغذاء (Food): زيادة إنتاجية القمح والأرز والذرة 15-25%، مع غسيل أملاح ذكي تلقائي يفتح الصمام عند EC &gt; 4 dS/m ويغلقه عند EC &lt; 2 dS/m.</a:t>
-            </a:r>
-          </a:p>
-          <a:p>
-            <a:pPr algn="r">
-              <a:defRPr sz="950">
-                <a:solidFill>
-                  <a:srgbClr val="F8FAFC"/>
-                </a:solidFill>
-              </a:defRPr>
-            </a:pPr>
-            <a:r>
-              <a:t>🌿 النظم البيئية (Ecosystems): 20 محطة أراضٍ رطبة اصطناعية (4,760 فدان) تعالج 200M م³/سنة حيوياً وتحمي بحيرات الدلتا الشمالية، وتحتجز 100k طن CO₂ (شهادات Verra VM0033).</a:t>
-            </a:r>
-          </a:p>
-        </p:txBody>
-      </p:sp>
-      <p:sp>
-        <p:nvSpPr>
-          <p:cNvPr id="7" name="Rounded Rectangle 6"/>
+              <a:t>📊 مصفوفة فرز WEFE الرسمية وبطاقة قياس المرونة</a:t>
+            </a:r>
+          </a:p>
+        </p:txBody>
+      </p:sp>
+      <p:sp>
+        <p:nvSpPr>
+          <p:cNvPr id="24" name="Rounded Rectangle 23"/>
           <p:cNvSpPr/>
           <p:nvPr/>
         </p:nvSpPr>
         <p:spPr>
           <a:xfrm>
-            <a:off x="6217920" y="4069080"/>
-            <a:ext cx="5242255" cy="2331720"/>
+            <a:off x="6400800" y="4507992"/>
+            <a:ext cx="4876495" cy="310896"/>
           </a:xfrm>
           <a:prstGeom prst="roundRect">
-            <a:avLst/>
+            <a:avLst>
+              <a:gd name="adj" fmla="val 35000"/>
+            </a:avLst>
           </a:prstGeom>
           <a:solidFill>
-            <a:srgbClr val="0F2240"/>
+            <a:srgbClr val="162D52"/>
           </a:solidFill>
           <a:ln w="12700">
             <a:solidFill>
@@ -3962,23 +5332,33 @@
           </a:fontRef>
         </p:style>
         <p:txBody>
-          <a:bodyPr rtlCol="0" anchor="ctr"/>
-          <a:lstStyle/>
-          <a:p>
-            <a:pPr algn="ctr"/>
-          </a:p>
-        </p:txBody>
-      </p:sp>
-      <p:sp>
-        <p:nvSpPr>
-          <p:cNvPr id="8" name="TextBox 7"/>
+          <a:bodyPr rtlCol="0" anchor="ctr" wrap="square" tIns="0" bIns="0" lIns="0" rIns="0"/>
+          <a:lstStyle/>
+          <a:p>
+            <a:pPr algn="r">
+              <a:defRPr sz="1150" b="1">
+                <a:solidFill>
+                  <a:srgbClr val="F0C860"/>
+                </a:solidFill>
+                <a:latin typeface="Segoe UI"/>
+              </a:defRPr>
+            </a:pPr>
+            <a:r>
+              <a:t> التقييم المركب: 92 / 100 | تصنيف المرونة: HIGH </a:t>
+            </a:r>
+          </a:p>
+        </p:txBody>
+      </p:sp>
+      <p:sp>
+        <p:nvSpPr>
+          <p:cNvPr id="25" name="TextBox 24"/>
           <p:cNvSpPr txBox="1"/>
           <p:nvPr/>
         </p:nvSpPr>
         <p:spPr>
           <a:xfrm>
-            <a:off x="6400800" y="4206240"/>
-            <a:ext cx="4876495" cy="365760"/>
+            <a:off x="6419088" y="4873752"/>
+            <a:ext cx="4839919" cy="1527048"/>
           </a:xfrm>
           <a:prstGeom prst="rect">
             <a:avLst/>
@@ -3992,133 +5372,112 @@
           <a:lstStyle/>
           <a:p>
             <a:pPr algn="r">
-              <a:defRPr sz="1200" b="1">
+              <a:lnSpc>
+                <a:spcPct val="125000"/>
+              </a:lnSpc>
+              <a:spcAft>
+                <a:spcPts val="600"/>
+              </a:spcAft>
+            </a:pPr>
+            <a:r>
+              <a:rPr sz="1150" b="1">
                 <a:solidFill>
                   <a:srgbClr val="15B5A4"/>
                 </a:solidFill>
-              </a:defRPr>
-            </a:pPr>
-            <a:r>
-              <a:t>📊 2. مصفوفة فرز WEFE الرسمية وبطاقة قياس المرونة</a:t>
-            </a:r>
-          </a:p>
-        </p:txBody>
-      </p:sp>
-      <p:sp>
-        <p:nvSpPr>
-          <p:cNvPr id="9" name="TextBox 8"/>
-          <p:cNvSpPr txBox="1"/>
-          <p:nvPr/>
-        </p:nvSpPr>
-        <p:spPr>
-          <a:xfrm>
-            <a:off x="6400800" y="4572000"/>
-            <a:ext cx="4876495" cy="1737360"/>
-          </a:xfrm>
-          <a:prstGeom prst="rect">
-            <a:avLst/>
-          </a:prstGeom>
-          <a:noFill/>
-        </p:spPr>
-        <p:txBody>
-          <a:bodyPr wrap="square" tIns="0" bIns="0" lIns="0" rIns="0">
-            <a:spAutoFit/>
-          </a:bodyPr>
-          <a:lstStyle/>
+                <a:latin typeface="Segoe UI"/>
+              </a:rPr>
+              <a:t>• درجات الأبعاد الخمسة: </a:t>
+            </a:r>
+            <a:r>
+              <a:rPr sz="1150">
+                <a:solidFill>
+                  <a:srgbClr val="F8FAFC"/>
+                </a:solidFill>
+                <a:latin typeface="Segoe UI"/>
+              </a:rPr>
+              <a:t>المياه: 10/10 | الطاقة: 8/10 | الغذاء: 10/10 | النظم البيئية: 8/10 | الرقمنة: 9/10.</a:t>
+            </a:r>
+          </a:p>
           <a:p>
             <a:pPr algn="r">
-              <a:defRPr sz="850">
+              <a:lnSpc>
+                <a:spcPct val="125000"/>
+              </a:lnSpc>
+              <a:spcAft>
+                <a:spcPts val="600"/>
+              </a:spcAft>
+            </a:pPr>
+            <a:r>
+              <a:rPr sz="1150" b="1">
+                <a:solidFill>
+                  <a:srgbClr val="15B5A4"/>
+                </a:solidFill>
+                <a:latin typeface="Segoe UI"/>
+              </a:rPr>
+              <a:t>• الممكنات الرقمية: </a:t>
+            </a:r>
+            <a:r>
+              <a:rPr sz="1150">
                 <a:solidFill>
                   <a:srgbClr val="F8FAFC"/>
                 </a:solidFill>
-              </a:defRPr>
-            </a:pPr>
-            <a:r>
-              <a:t>• بعد المياه (الدرجة: 10/10): وفر 150M م³/سنة؛ تثبيت منسوب الماء الأرضي عند 0.8-1.2م.</a:t>
+                <a:latin typeface="Segoe UI"/>
+              </a:rPr>
+              <a:t>5,000 عقدة IoT مع توأم رقمي هيدروليكي للتحكم عن بُعد والتنبؤ بالأعطال لحظياً.</a:t>
             </a:r>
           </a:p>
           <a:p>
             <a:pPr algn="r">
-              <a:defRPr sz="850">
+              <a:lnSpc>
+                <a:spcPct val="125000"/>
+              </a:lnSpc>
+              <a:spcAft>
+                <a:spcPts val="0"/>
+              </a:spcAft>
+            </a:pPr>
+            <a:r>
+              <a:rPr sz="1150" b="1">
+                <a:solidFill>
+                  <a:srgbClr val="15B5A4"/>
+                </a:solidFill>
+                <a:latin typeface="Segoe UI"/>
+              </a:rPr>
+              <a:t>• استيعاب الصدمات المناخية: </a:t>
+            </a:r>
+            <a:r>
+              <a:rPr sz="1150">
                 <a:solidFill>
                   <a:srgbClr val="F8FAFC"/>
                 </a:solidFill>
-              </a:defRPr>
-            </a:pPr>
-            <a:r>
-              <a:t>• بعد الطاقة (الدرجة: 8/10): 50 MW شمسية؛ 90 GWh/سنة؛ خفض تكاليف الضخ 40%.</a:t>
-            </a:r>
-          </a:p>
-          <a:p>
-            <a:pPr algn="r">
-              <a:defRPr sz="850">
-                <a:solidFill>
-                  <a:srgbClr val="F8FAFC"/>
-                </a:solidFill>
-              </a:defRPr>
-            </a:pPr>
-            <a:r>
-              <a:t>• بعد الغذاء (الدرجة: 10/10): زيادة المحاصيل 15-25%؛ دعم أمن الغذاء لـ 200,000 مزارع.</a:t>
-            </a:r>
-          </a:p>
-          <a:p>
-            <a:pPr algn="r">
-              <a:defRPr sz="850">
-                <a:solidFill>
-                  <a:srgbClr val="F8FAFC"/>
-                </a:solidFill>
-              </a:defRPr>
-            </a:pPr>
-            <a:r>
-              <a:t>• بعد النظم البيئية (الدرجة: 8/10): 4,760 فدان رطبة؛ كربون أزرق؛ حماية الثروة السمكية.</a:t>
-            </a:r>
-          </a:p>
-          <a:p>
-            <a:pPr algn="r">
-              <a:defRPr sz="850">
-                <a:solidFill>
-                  <a:srgbClr val="F8FAFC"/>
-                </a:solidFill>
-              </a:defRPr>
-            </a:pPr>
-            <a:r>
-              <a:t>• الممكنات الرقمية (الدرجة: 9/10): 5,000 عقدة IoT؛ توأم رقمي؛ رصد تلاعب لحظي مشفر.</a:t>
-            </a:r>
-          </a:p>
-          <a:p>
-            <a:pPr algn="r">
-              <a:defRPr sz="850">
-                <a:solidFill>
-                  <a:srgbClr val="F0C860"/>
-                </a:solidFill>
-              </a:defRPr>
-            </a:pPr>
-            <a:r>
-              <a:t>• التقييم المركب لمشروع WEFE: 92 / 100 | بطاقة قياس المرونة: HIGH عبر الأبعاد الـ 5.</a:t>
-            </a:r>
-          </a:p>
-        </p:txBody>
-      </p:sp>
-      <p:sp>
-        <p:nvSpPr>
-          <p:cNvPr id="10" name="Rounded Rectangle 9"/>
+                <a:latin typeface="Segoe UI"/>
+              </a:rPr>
+              <a:t>مرونة عالية في مواجهة موجات الجفاف المتكررة وحماية التربة من نوبات التملح المفاجئ.</a:t>
+            </a:r>
+          </a:p>
+        </p:txBody>
+      </p:sp>
+      <p:sp>
+        <p:nvSpPr>
+          <p:cNvPr id="26" name="Rounded Rectangle 25"/>
           <p:cNvSpPr/>
           <p:nvPr/>
         </p:nvSpPr>
         <p:spPr>
           <a:xfrm>
             <a:off x="731520" y="4069080"/>
-            <a:ext cx="5212080" cy="2331720"/>
+            <a:ext cx="5212080" cy="2423160"/>
           </a:xfrm>
           <a:prstGeom prst="roundRect">
-            <a:avLst/>
+            <a:avLst>
+              <a:gd name="adj" fmla="val 8000"/>
+            </a:avLst>
           </a:prstGeom>
           <a:solidFill>
             <a:srgbClr val="0F2240"/>
           </a:solidFill>
-          <a:ln w="12700">
+          <a:ln w="16510">
             <a:solidFill>
-              <a:srgbClr val="15B5A4"/>
+              <a:srgbClr val="10B981"/>
             </a:solidFill>
           </a:ln>
         </p:spPr>
@@ -4146,14 +5505,14 @@
       </p:sp>
       <p:sp>
         <p:nvSpPr>
-          <p:cNvPr id="11" name="TextBox 10"/>
+          <p:cNvPr id="27" name="TextBox 26"/>
           <p:cNvSpPr txBox="1"/>
           <p:nvPr/>
         </p:nvSpPr>
         <p:spPr>
           <a:xfrm>
-            <a:off x="914400" y="4206240"/>
-            <a:ext cx="4846320" cy="365760"/>
+            <a:off x="932688" y="4178808"/>
+            <a:ext cx="4809744" cy="347472"/>
           </a:xfrm>
           <a:prstGeom prst="rect">
             <a:avLst/>
@@ -4167,28 +5526,86 @@
           <a:lstStyle/>
           <a:p>
             <a:pPr algn="r">
-              <a:defRPr sz="1200" b="1">
+              <a:defRPr sz="1450" b="1">
                 <a:solidFill>
                   <a:srgbClr val="10B981"/>
                 </a:solidFill>
+                <a:latin typeface="Segoe UI"/>
               </a:defRPr>
             </a:pPr>
             <a:r>
-              <a:t>💎 3. كيف يعزز تكامل WEFE الجدوى البنكية للمشروع</a:t>
-            </a:r>
-          </a:p>
-        </p:txBody>
-      </p:sp>
-      <p:sp>
-        <p:nvSpPr>
-          <p:cNvPr id="12" name="TextBox 11"/>
+              <a:t>💎 كيف يعزز تكامل WEFE الجدوى البنكية للمشروع</a:t>
+            </a:r>
+          </a:p>
+        </p:txBody>
+      </p:sp>
+      <p:sp>
+        <p:nvSpPr>
+          <p:cNvPr id="28" name="Rounded Rectangle 27"/>
+          <p:cNvSpPr/>
+          <p:nvPr/>
+        </p:nvSpPr>
+        <p:spPr>
+          <a:xfrm>
+            <a:off x="914400" y="4507992"/>
+            <a:ext cx="4846320" cy="310896"/>
+          </a:xfrm>
+          <a:prstGeom prst="roundRect">
+            <a:avLst>
+              <a:gd name="adj" fmla="val 35000"/>
+            </a:avLst>
+          </a:prstGeom>
+          <a:solidFill>
+            <a:srgbClr val="162D52"/>
+          </a:solidFill>
+          <a:ln w="12700">
+            <a:solidFill>
+              <a:srgbClr val="10B981"/>
+            </a:solidFill>
+          </a:ln>
+        </p:spPr>
+        <p:style>
+          <a:lnRef idx="1">
+            <a:schemeClr val="accent1"/>
+          </a:lnRef>
+          <a:fillRef idx="3">
+            <a:schemeClr val="accent1"/>
+          </a:fillRef>
+          <a:effectRef idx="2">
+            <a:schemeClr val="accent1"/>
+          </a:effectRef>
+          <a:fontRef idx="minor">
+            <a:schemeClr val="lt1"/>
+          </a:fontRef>
+        </p:style>
+        <p:txBody>
+          <a:bodyPr rtlCol="0" anchor="ctr" wrap="square" tIns="0" bIns="0" lIns="0" rIns="0"/>
+          <a:lstStyle/>
+          <a:p>
+            <a:pPr algn="r">
+              <a:defRPr sz="1150" b="1">
+                <a:solidFill>
+                  <a:srgbClr val="F0C860"/>
+                </a:solidFill>
+                <a:latin typeface="Segoe UI"/>
+              </a:defRPr>
+            </a:pPr>
+            <a:r>
+              <a:t> DSCR = 1.35x | فترة استرداد 0.48 سنة للري الذكي </a:t>
+            </a:r>
+          </a:p>
+        </p:txBody>
+      </p:sp>
+      <p:sp>
+        <p:nvSpPr>
+          <p:cNvPr id="29" name="TextBox 28"/>
           <p:cNvSpPr txBox="1"/>
           <p:nvPr/>
         </p:nvSpPr>
         <p:spPr>
           <a:xfrm>
-            <a:off x="914400" y="4572000"/>
-            <a:ext cx="4846320" cy="1737360"/>
+            <a:off x="932688" y="4873752"/>
+            <a:ext cx="4809744" cy="1527048"/>
           </a:xfrm>
           <a:prstGeom prst="rect">
             <a:avLst/>
@@ -4202,50 +5619,114 @@
           <a:lstStyle/>
           <a:p>
             <a:pPr algn="r">
-              <a:defRPr sz="850">
+              <a:lnSpc>
+                <a:spcPct val="125000"/>
+              </a:lnSpc>
+              <a:spcAft>
+                <a:spcPts val="500"/>
+              </a:spcAft>
+            </a:pPr>
+            <a:r>
+              <a:rPr sz="1150" b="1">
+                <a:solidFill>
+                  <a:srgbClr val="F0C860"/>
+                </a:solidFill>
+                <a:latin typeface="Segoe UI"/>
+              </a:rPr>
+              <a:t>• الاكتفاء الذاتي التشغيلي: </a:t>
+            </a:r>
+            <a:r>
+              <a:rPr sz="1150">
                 <a:solidFill>
                   <a:srgbClr val="F8FAFC"/>
                 </a:solidFill>
-              </a:defRPr>
-            </a:pPr>
-            <a:r>
-              <a:t>• الاكتفاء الذاتي من تكاليف التشغيل: الطاقة الشمسية المصدرة تسدد فواتير كهرباء الطلمبات، مما يحمي نسبة خدمة الدين (DSCR = 1.35x).</a:t>
+                <a:latin typeface="Segoe UI"/>
+              </a:rPr>
+              <a:t>الطاقة الشمسية تسدد تكاليف كهرباء الطلمبات، مما يحمي نسبة خدمة الدين (DSCR = 1.35x).</a:t>
             </a:r>
           </a:p>
           <a:p>
             <a:pPr algn="r">
-              <a:defRPr sz="850">
+              <a:lnSpc>
+                <a:spcPct val="125000"/>
+              </a:lnSpc>
+              <a:spcAft>
+                <a:spcPts val="500"/>
+              </a:spcAft>
+            </a:pPr>
+            <a:r>
+              <a:rPr sz="1150" b="1">
+                <a:solidFill>
+                  <a:srgbClr val="10B981"/>
+                </a:solidFill>
+                <a:latin typeface="Segoe UI"/>
+              </a:rPr>
+              <a:t>• قيمة التكلفة المتجنبة: </a:t>
+            </a:r>
+            <a:r>
+              <a:rPr sz="1150">
                 <a:solidFill>
                   <a:srgbClr val="F8FAFC"/>
                 </a:solidFill>
-              </a:defRPr>
-            </a:pPr>
-            <a:r>
-              <a:t>• قيمة التكلفة المتجنبة (Avoided Costs): توفير 150M م³ مياه يعادل 52.5M دولار/سنة بتكلفة البديل (0.35$/م³)، محققاً فترة استرداد 0.48 سنة للري الذكي.</a:t>
+                <a:latin typeface="Segoe UI"/>
+              </a:rPr>
+              <a:t>توفير 150M م³ يعادل 52.5 مليون دولار سنوياً، محققاً استرداداً خلال 0.48 سنة للري الذكي.</a:t>
             </a:r>
           </a:p>
           <a:p>
             <a:pPr algn="r">
-              <a:defRPr sz="850">
+              <a:lnSpc>
+                <a:spcPct val="125000"/>
+              </a:lnSpc>
+              <a:spcAft>
+                <a:spcPts val="500"/>
+              </a:spcAft>
+            </a:pPr>
+            <a:r>
+              <a:rPr sz="1150" b="1">
+                <a:solidFill>
+                  <a:srgbClr val="10B981"/>
+                </a:solidFill>
+                <a:latin typeface="Segoe UI"/>
+              </a:rPr>
+              <a:t>• تنوع التدفقات النقدية: </a:t>
+            </a:r>
+            <a:r>
+              <a:rPr sz="1150">
                 <a:solidFill>
                   <a:srgbClr val="F8FAFC"/>
                 </a:solidFill>
-              </a:defRPr>
-            </a:pPr>
-            <a:r>
-              <a:t>• تنوع التدفقات النقدية الإيرادية: وفر طاقة ($8M) + تصدير شبكة ($3M) + مياه متجنبة ($5M) + أرصدة كربون ($0.5M) ورسوم صيانة.</a:t>
+                <a:latin typeface="Segoe UI"/>
+              </a:rPr>
+              <a:t>وفر طاقة ($8M) + تصدير شبكة ($3M) + مياه ($5M) + أرصدة كربون ($0.5M).</a:t>
             </a:r>
           </a:p>
           <a:p>
             <a:pPr algn="r">
-              <a:defRPr sz="850">
+              <a:lnSpc>
+                <a:spcPct val="125000"/>
+              </a:lnSpc>
+              <a:spcAft>
+                <a:spcPts val="0"/>
+              </a:spcAft>
+            </a:pPr>
+            <a:r>
+              <a:rPr sz="1150" b="1">
+                <a:solidFill>
+                  <a:srgbClr val="10B981"/>
+                </a:solidFill>
+                <a:latin typeface="Segoe UI"/>
+              </a:rPr>
+              <a:t>• انعدام النزاعات الاجتماعية: </a:t>
+            </a:r>
+            <a:r>
+              <a:rPr sz="1150">
                 <a:solidFill>
                   <a:srgbClr val="F8FAFC"/>
                 </a:solidFill>
-              </a:defRPr>
-            </a:pPr>
-            <a:r>
-              <a:t>• انعدام النزاعات الاجتماعية: تطوير موضعي (In-situ) في أراضي الدلتا القديمة دون تحويل المياه بعيداً عن صغار المزارعين (بخلاف مشاريع بحر البقر والمحسمة).</a:t>
+                <a:latin typeface="Segoe UI"/>
+              </a:rPr>
+              <a:t>تطوير موضعي (In-situ) في أراضي الدلتا القديمة دون تهجير أو نزاع على المياه.</a:t>
             </a:r>
           </a:p>
         </p:txBody>
@@ -4313,14 +5794,116 @@
       </p:sp>
       <p:sp>
         <p:nvSpPr>
-          <p:cNvPr id="3" name="TextBox 2"/>
+          <p:cNvPr id="3" name="Rounded Rectangle 2"/>
+          <p:cNvSpPr/>
+          <p:nvPr/>
+        </p:nvSpPr>
+        <p:spPr>
+          <a:xfrm>
+            <a:off x="731520" y="146304"/>
+            <a:ext cx="10728655" cy="36576"/>
+          </a:xfrm>
+          <a:prstGeom prst="roundRect">
+            <a:avLst>
+              <a:gd name="adj" fmla="val 50000"/>
+            </a:avLst>
+          </a:prstGeom>
+          <a:solidFill>
+            <a:srgbClr val="15B5A4"/>
+          </a:solidFill>
+          <a:ln>
+            <a:noFill/>
+          </a:ln>
+        </p:spPr>
+        <p:style>
+          <a:lnRef idx="1">
+            <a:schemeClr val="accent1"/>
+          </a:lnRef>
+          <a:fillRef idx="3">
+            <a:schemeClr val="accent1"/>
+          </a:fillRef>
+          <a:effectRef idx="2">
+            <a:schemeClr val="accent1"/>
+          </a:effectRef>
+          <a:fontRef idx="minor">
+            <a:schemeClr val="lt1"/>
+          </a:fontRef>
+        </p:style>
+        <p:txBody>
+          <a:bodyPr rtlCol="0" anchor="ctr"/>
+          <a:lstStyle/>
+          <a:p>
+            <a:pPr algn="ctr"/>
+          </a:p>
+        </p:txBody>
+      </p:sp>
+      <p:sp>
+        <p:nvSpPr>
+          <p:cNvPr id="4" name="Rounded Rectangle 3"/>
+          <p:cNvSpPr/>
+          <p:nvPr/>
+        </p:nvSpPr>
+        <p:spPr>
+          <a:xfrm>
+            <a:off x="7253935" y="292608"/>
+            <a:ext cx="4206240" cy="292608"/>
+          </a:xfrm>
+          <a:prstGeom prst="roundRect">
+            <a:avLst>
+              <a:gd name="adj" fmla="val 50000"/>
+            </a:avLst>
+          </a:prstGeom>
+          <a:solidFill>
+            <a:srgbClr val="162D52"/>
+          </a:solidFill>
+          <a:ln w="15240">
+            <a:solidFill>
+              <a:srgbClr val="15B5A4"/>
+            </a:solidFill>
+          </a:ln>
+        </p:spPr>
+        <p:style>
+          <a:lnRef idx="1">
+            <a:schemeClr val="accent1"/>
+          </a:lnRef>
+          <a:fillRef idx="3">
+            <a:schemeClr val="accent1"/>
+          </a:fillRef>
+          <a:effectRef idx="2">
+            <a:schemeClr val="accent1"/>
+          </a:effectRef>
+          <a:fontRef idx="minor">
+            <a:schemeClr val="lt1"/>
+          </a:fontRef>
+        </p:style>
+        <p:txBody>
+          <a:bodyPr rtlCol="0" anchor="ctr" wrap="none" tIns="0" bIns="0" lIns="0" rIns="0"/>
+          <a:lstStyle/>
+          <a:p>
+            <a:pPr algn="ctr">
+              <a:defRPr sz="1050" b="1">
+                <a:solidFill>
+                  <a:srgbClr val="15B5A4"/>
+                </a:solidFill>
+                <a:latin typeface="Segoe UI"/>
+              </a:defRPr>
+            </a:pPr>
+            <a:r>
+              <a:t>الشريحة 3 من 3 | عرض تنفيذي في 5 دقائق | محور WEFE المقاوم للمناخ</a:t>
+            </a:r>
+          </a:p>
+        </p:txBody>
+      </p:sp>
+      <p:sp>
+        <p:nvSpPr>
+          <p:cNvPr id="5" name="TextBox 4"/>
           <p:cNvSpPr txBox="1"/>
           <p:nvPr/>
         </p:nvSpPr>
         <p:spPr>
           <a:xfrm>
-            <a:off x="731520" y="365760"/>
-            <a:ext cx="10728655" cy="1051560"/>
+            <a:off x="731520" y="658368"/>
+            <a:ext cx="10728655" cy="804672"/>
           </a:xfrm>
           <a:prstGeom prst="rect">
             <a:avLst/>
@@ -4334,58 +5917,689 @@
           <a:lstStyle/>
           <a:p>
             <a:pPr algn="r">
-              <a:defRPr sz="950" b="1">
-                <a:solidFill>
-                  <a:srgbClr val="15B5A4"/>
-                </a:solidFill>
+              <a:lnSpc>
+                <a:spcPct val="115000"/>
+              </a:lnSpc>
+              <a:defRPr sz="2200" b="1">
+                <a:solidFill>
+                  <a:srgbClr val="F8FAFC"/>
+                </a:solidFill>
+                <a:latin typeface="Segoe UI"/>
               </a:defRPr>
             </a:pPr>
             <a:r>
-              <a:t>الشريحة 3 من 3 | عرض تنفيذي في 5 دقائق | برنامج تمويل المرونة ومحور WEFE</a:t>
+              <a:t>هيكل رأس المال المختلط، الجاهزية، ومسار التوسع الإقليمي</a:t>
             </a:r>
           </a:p>
           <a:p>
             <a:pPr algn="r">
-              <a:defRPr sz="1900" b="1">
-                <a:solidFill>
-                  <a:srgbClr val="F8FAFC"/>
-                </a:solidFill>
+              <a:lnSpc>
+                <a:spcPct val="120000"/>
+              </a:lnSpc>
+              <a:defRPr sz="1200">
+                <a:solidFill>
+                  <a:srgbClr val="F0C860"/>
+                </a:solidFill>
+                <a:latin typeface="Segoe UI"/>
               </a:defRPr>
             </a:pPr>
             <a:r>
-              <a:t>هيكل رأس المال المختلط، الجاهزية، ومسار التوسع الإقليمي</a:t>
-            </a:r>
-          </a:p>
-          <a:p>
-            <a:pPr algn="r">
-              <a:defRPr sz="1100">
-                <a:solidFill>
-                  <a:srgbClr val="F0C860"/>
-                </a:solidFill>
-              </a:defRPr>
-            </a:pPr>
-            <a:r>
-              <a:t>4. الميزانية والجهات الممولة | 5. الجاهزية والحقل التجريبي | 6. مؤشرات الأداء والتوسع الإقليمي</a:t>
-            </a:r>
-          </a:p>
-        </p:txBody>
-      </p:sp>
-      <p:sp>
-        <p:nvSpPr>
-          <p:cNvPr id="4" name="Rounded Rectangle 3"/>
+              <a:t>4. الميزانية والجهات الممولة | 5. الجاهزية ووحدة الاختبار | 6. مؤشرات الأداء ومسار التوسع الإقليمي</a:t>
+            </a:r>
+          </a:p>
+        </p:txBody>
+      </p:sp>
+      <p:sp>
+        <p:nvSpPr>
+          <p:cNvPr id="6" name="Rounded Rectangle 5"/>
           <p:cNvSpPr/>
           <p:nvPr/>
         </p:nvSpPr>
         <p:spPr>
           <a:xfrm>
-            <a:off x="6217920" y="1463040"/>
-            <a:ext cx="5242255" cy="2560320"/>
+            <a:off x="6217920" y="1536192"/>
+            <a:ext cx="5242255" cy="2423160"/>
           </a:xfrm>
           <a:prstGeom prst="roundRect">
-            <a:avLst/>
+            <a:avLst>
+              <a:gd name="adj" fmla="val 8000"/>
+            </a:avLst>
           </a:prstGeom>
           <a:solidFill>
             <a:srgbClr val="0F2240"/>
+          </a:solidFill>
+          <a:ln w="16510">
+            <a:solidFill>
+              <a:srgbClr val="D4A843"/>
+            </a:solidFill>
+          </a:ln>
+        </p:spPr>
+        <p:style>
+          <a:lnRef idx="1">
+            <a:schemeClr val="accent1"/>
+          </a:lnRef>
+          <a:fillRef idx="3">
+            <a:schemeClr val="accent1"/>
+          </a:fillRef>
+          <a:effectRef idx="2">
+            <a:schemeClr val="accent1"/>
+          </a:effectRef>
+          <a:fontRef idx="minor">
+            <a:schemeClr val="lt1"/>
+          </a:fontRef>
+        </p:style>
+        <p:txBody>
+          <a:bodyPr rtlCol="0" anchor="ctr"/>
+          <a:lstStyle/>
+          <a:p>
+            <a:pPr algn="ctr"/>
+          </a:p>
+        </p:txBody>
+      </p:sp>
+      <p:sp>
+        <p:nvSpPr>
+          <p:cNvPr id="7" name="TextBox 6"/>
+          <p:cNvSpPr txBox="1"/>
+          <p:nvPr/>
+        </p:nvSpPr>
+        <p:spPr>
+          <a:xfrm>
+            <a:off x="6419088" y="1645920"/>
+            <a:ext cx="4839919" cy="347472"/>
+          </a:xfrm>
+          <a:prstGeom prst="rect">
+            <a:avLst/>
+          </a:prstGeom>
+          <a:noFill/>
+        </p:spPr>
+        <p:txBody>
+          <a:bodyPr wrap="square" tIns="0" bIns="0" lIns="0" rIns="0">
+            <a:spAutoFit/>
+          </a:bodyPr>
+          <a:lstStyle/>
+          <a:p>
+            <a:pPr algn="r">
+              <a:defRPr sz="1450" b="1">
+                <a:solidFill>
+                  <a:srgbClr val="F0C860"/>
+                </a:solidFill>
+                <a:latin typeface="Segoe UI"/>
+              </a:defRPr>
+            </a:pPr>
+            <a:r>
+              <a:t>💰 1. إجمالي التكلفة (420M$) وهيكل التمويل المختلط</a:t>
+            </a:r>
+          </a:p>
+        </p:txBody>
+      </p:sp>
+      <p:sp>
+        <p:nvSpPr>
+          <p:cNvPr id="8" name="Rounded Rectangle 7"/>
+          <p:cNvSpPr/>
+          <p:nvPr/>
+        </p:nvSpPr>
+        <p:spPr>
+          <a:xfrm>
+            <a:off x="6400800" y="1975104"/>
+            <a:ext cx="4876495" cy="310896"/>
+          </a:xfrm>
+          <a:prstGeom prst="roundRect">
+            <a:avLst>
+              <a:gd name="adj" fmla="val 35000"/>
+            </a:avLst>
+          </a:prstGeom>
+          <a:solidFill>
+            <a:srgbClr val="162D52"/>
+          </a:solidFill>
+          <a:ln w="12700">
+            <a:solidFill>
+              <a:srgbClr val="D4A843"/>
+            </a:solidFill>
+          </a:ln>
+        </p:spPr>
+        <p:style>
+          <a:lnRef idx="1">
+            <a:schemeClr val="accent1"/>
+          </a:lnRef>
+          <a:fillRef idx="3">
+            <a:schemeClr val="accent1"/>
+          </a:fillRef>
+          <a:effectRef idx="2">
+            <a:schemeClr val="accent1"/>
+          </a:effectRef>
+          <a:fontRef idx="minor">
+            <a:schemeClr val="lt1"/>
+          </a:fontRef>
+        </p:style>
+        <p:txBody>
+          <a:bodyPr rtlCol="0" anchor="ctr" wrap="square" tIns="0" bIns="0" lIns="0" rIns="0"/>
+          <a:lstStyle/>
+          <a:p>
+            <a:pPr algn="r">
+              <a:defRPr sz="1150" b="1">
+                <a:solidFill>
+                  <a:srgbClr val="F0C860"/>
+                </a:solidFill>
+                <a:latin typeface="Segoe UI"/>
+              </a:defRPr>
+            </a:pPr>
+            <a:r>
+              <a:t> CAPEX: 420M$ (4,200 $/فدان) | EIRR = 21.4% | استرداد 8 سنوات </a:t>
+            </a:r>
+          </a:p>
+        </p:txBody>
+      </p:sp>
+      <p:sp>
+        <p:nvSpPr>
+          <p:cNvPr id="9" name="TextBox 8"/>
+          <p:cNvSpPr txBox="1"/>
+          <p:nvPr/>
+        </p:nvSpPr>
+        <p:spPr>
+          <a:xfrm>
+            <a:off x="6419088" y="2340864"/>
+            <a:ext cx="4839919" cy="1527048"/>
+          </a:xfrm>
+          <a:prstGeom prst="rect">
+            <a:avLst/>
+          </a:prstGeom>
+          <a:noFill/>
+        </p:spPr>
+        <p:txBody>
+          <a:bodyPr wrap="square" tIns="0" bIns="0" lIns="0" rIns="0">
+            <a:spAutoFit/>
+          </a:bodyPr>
+          <a:lstStyle/>
+          <a:p>
+            <a:pPr algn="r">
+              <a:lnSpc>
+                <a:spcPct val="125000"/>
+              </a:lnSpc>
+              <a:spcAft>
+                <a:spcPts val="500"/>
+              </a:spcAft>
+            </a:pPr>
+            <a:r>
+              <a:rPr sz="1150" b="1">
+                <a:solidFill>
+                  <a:srgbClr val="F0C860"/>
+                </a:solidFill>
+                <a:latin typeface="Segoe UI"/>
+              </a:rPr>
+              <a:t>• 15% منح ومعونات (63M$): </a:t>
+            </a:r>
+            <a:r>
+              <a:rPr sz="1150">
+                <a:solidFill>
+                  <a:srgbClr val="F8FAFC"/>
+                </a:solidFill>
+                <a:latin typeface="Segoe UI"/>
+              </a:rPr>
+              <a:t>من GCF و AfDB و EU للحقل التجريبي والتوأم الرقمي وبناء القدرات.</a:t>
+            </a:r>
+          </a:p>
+          <a:p>
+            <a:pPr algn="r">
+              <a:lnSpc>
+                <a:spcPct val="125000"/>
+              </a:lnSpc>
+              <a:spcAft>
+                <a:spcPts val="500"/>
+              </a:spcAft>
+            </a:pPr>
+            <a:r>
+              <a:rPr sz="1150" b="1">
+                <a:solidFill>
+                  <a:srgbClr val="F8FAFC"/>
+                </a:solidFill>
+                <a:latin typeface="Segoe UI"/>
+              </a:rPr>
+              <a:t>• 20% مساهمة حكومية (84M$): </a:t>
+            </a:r>
+            <a:r>
+              <a:rPr sz="1150">
+                <a:solidFill>
+                  <a:srgbClr val="F8FAFC"/>
+                </a:solidFill>
+                <a:latin typeface="Segoe UI"/>
+              </a:rPr>
+              <a:t>أراضٍ ومحطات طلمبات قائمة وكوادر هيئة الصرف (EPADP).</a:t>
+            </a:r>
+          </a:p>
+          <a:p>
+            <a:pPr algn="r">
+              <a:lnSpc>
+                <a:spcPct val="125000"/>
+              </a:lnSpc>
+              <a:spcAft>
+                <a:spcPts val="500"/>
+              </a:spcAft>
+            </a:pPr>
+            <a:r>
+              <a:rPr sz="1150" b="1">
+                <a:solidFill>
+                  <a:srgbClr val="F8FAFC"/>
+                </a:solidFill>
+                <a:latin typeface="Segoe UI"/>
+              </a:rPr>
+              <a:t>• 40% قروض ميسرة (168M$): </a:t>
+            </a:r>
+            <a:r>
+              <a:rPr sz="1150">
+                <a:solidFill>
+                  <a:srgbClr val="F8FAFC"/>
+                </a:solidFill>
+                <a:latin typeface="Segoe UI"/>
+              </a:rPr>
+              <a:t>البنك الدولي (NDP V) وبنك التنمية الأفريقي (سداد 20-25 سنة).</a:t>
+            </a:r>
+          </a:p>
+          <a:p>
+            <a:pPr algn="r">
+              <a:lnSpc>
+                <a:spcPct val="125000"/>
+              </a:lnSpc>
+              <a:spcAft>
+                <a:spcPts val="0"/>
+              </a:spcAft>
+            </a:pPr>
+            <a:r>
+              <a:rPr sz="1150" b="1">
+                <a:solidFill>
+                  <a:srgbClr val="F0C860"/>
+                </a:solidFill>
+                <a:latin typeface="Segoe UI"/>
+              </a:rPr>
+              <a:t>• 25% شراكة PPP (105M$): </a:t>
+            </a:r>
+            <a:r>
+              <a:rPr sz="1150">
+                <a:solidFill>
+                  <a:srgbClr val="F8FAFC"/>
+                </a:solidFill>
+                <a:latin typeface="Segoe UI"/>
+              </a:rPr>
+              <a:t>مستثمرون لمكون الطاقة الشمسية 50 MW مدعوماً بـ PPA | خدمة دين DSCR = 1.35x.</a:t>
+            </a:r>
+          </a:p>
+        </p:txBody>
+      </p:sp>
+      <p:sp>
+        <p:nvSpPr>
+          <p:cNvPr id="10" name="Rounded Rectangle 9"/>
+          <p:cNvSpPr/>
+          <p:nvPr/>
+        </p:nvSpPr>
+        <p:spPr>
+          <a:xfrm>
+            <a:off x="731520" y="1536192"/>
+            <a:ext cx="5212080" cy="2423160"/>
+          </a:xfrm>
+          <a:prstGeom prst="roundRect">
+            <a:avLst>
+              <a:gd name="adj" fmla="val 8000"/>
+            </a:avLst>
+          </a:prstGeom>
+          <a:solidFill>
+            <a:srgbClr val="0F2240"/>
+          </a:solidFill>
+          <a:ln w="16510">
+            <a:solidFill>
+              <a:srgbClr val="10B981"/>
+            </a:solidFill>
+          </a:ln>
+        </p:spPr>
+        <p:style>
+          <a:lnRef idx="1">
+            <a:schemeClr val="accent1"/>
+          </a:lnRef>
+          <a:fillRef idx="3">
+            <a:schemeClr val="accent1"/>
+          </a:fillRef>
+          <a:effectRef idx="2">
+            <a:schemeClr val="accent1"/>
+          </a:effectRef>
+          <a:fontRef idx="minor">
+            <a:schemeClr val="lt1"/>
+          </a:fontRef>
+        </p:style>
+        <p:txBody>
+          <a:bodyPr rtlCol="0" anchor="ctr"/>
+          <a:lstStyle/>
+          <a:p>
+            <a:pPr algn="ctr"/>
+          </a:p>
+        </p:txBody>
+      </p:sp>
+      <p:sp>
+        <p:nvSpPr>
+          <p:cNvPr id="11" name="TextBox 10"/>
+          <p:cNvSpPr txBox="1"/>
+          <p:nvPr/>
+        </p:nvSpPr>
+        <p:spPr>
+          <a:xfrm>
+            <a:off x="932688" y="1645920"/>
+            <a:ext cx="4809744" cy="347472"/>
+          </a:xfrm>
+          <a:prstGeom prst="rect">
+            <a:avLst/>
+          </a:prstGeom>
+          <a:noFill/>
+        </p:spPr>
+        <p:txBody>
+          <a:bodyPr wrap="square" tIns="0" bIns="0" lIns="0" rIns="0">
+            <a:spAutoFit/>
+          </a:bodyPr>
+          <a:lstStyle/>
+          <a:p>
+            <a:pPr algn="r">
+              <a:defRPr sz="1450" b="1">
+                <a:solidFill>
+                  <a:srgbClr val="10B981"/>
+                </a:solidFill>
+                <a:latin typeface="Segoe UI"/>
+              </a:defRPr>
+            </a:pPr>
+            <a:r>
+              <a:t>🚀 2. حالة الجاهزية ووحدة الاختبار (10 أفدنة)</a:t>
+            </a:r>
+          </a:p>
+        </p:txBody>
+      </p:sp>
+      <p:sp>
+        <p:nvSpPr>
+          <p:cNvPr id="12" name="Rounded Rectangle 11"/>
+          <p:cNvSpPr/>
+          <p:nvPr/>
+        </p:nvSpPr>
+        <p:spPr>
+          <a:xfrm>
+            <a:off x="914400" y="1975104"/>
+            <a:ext cx="4846320" cy="310896"/>
+          </a:xfrm>
+          <a:prstGeom prst="roundRect">
+            <a:avLst>
+              <a:gd name="adj" fmla="val 35000"/>
+            </a:avLst>
+          </a:prstGeom>
+          <a:solidFill>
+            <a:srgbClr val="162D52"/>
+          </a:solidFill>
+          <a:ln w="12700">
+            <a:solidFill>
+              <a:srgbClr val="10B981"/>
+            </a:solidFill>
+          </a:ln>
+        </p:spPr>
+        <p:style>
+          <a:lnRef idx="1">
+            <a:schemeClr val="accent1"/>
+          </a:lnRef>
+          <a:fillRef idx="3">
+            <a:schemeClr val="accent1"/>
+          </a:fillRef>
+          <a:effectRef idx="2">
+            <a:schemeClr val="accent1"/>
+          </a:effectRef>
+          <a:fontRef idx="minor">
+            <a:schemeClr val="lt1"/>
+          </a:fontRef>
+        </p:style>
+        <p:txBody>
+          <a:bodyPr rtlCol="0" anchor="ctr" wrap="square" tIns="0" bIns="0" lIns="0" rIns="0"/>
+          <a:lstStyle/>
+          <a:p>
+            <a:pPr algn="r">
+              <a:defRPr sz="1150" b="1">
+                <a:solidFill>
+                  <a:srgbClr val="F0C860"/>
+                </a:solidFill>
+                <a:latin typeface="Segoe UI"/>
+              </a:defRPr>
+            </a:pPr>
+            <a:r>
+              <a:t> خبرة 50 عاماً في 6M فدان | وحدة 10 أفدنة جاهزة فوراً </a:t>
+            </a:r>
+          </a:p>
+        </p:txBody>
+      </p:sp>
+      <p:sp>
+        <p:nvSpPr>
+          <p:cNvPr id="13" name="TextBox 12"/>
+          <p:cNvSpPr txBox="1"/>
+          <p:nvPr/>
+        </p:nvSpPr>
+        <p:spPr>
+          <a:xfrm>
+            <a:off x="932688" y="2340864"/>
+            <a:ext cx="4809744" cy="1527048"/>
+          </a:xfrm>
+          <a:prstGeom prst="rect">
+            <a:avLst/>
+          </a:prstGeom>
+          <a:noFill/>
+        </p:spPr>
+        <p:txBody>
+          <a:bodyPr wrap="square" tIns="0" bIns="0" lIns="0" rIns="0">
+            <a:spAutoFit/>
+          </a:bodyPr>
+          <a:lstStyle/>
+          <a:p>
+            <a:pPr algn="r">
+              <a:lnSpc>
+                <a:spcPct val="125000"/>
+              </a:lnSpc>
+              <a:spcAft>
+                <a:spcPts val="500"/>
+              </a:spcAft>
+            </a:pPr>
+            <a:r>
+              <a:rPr sz="1150" b="1">
+                <a:solidFill>
+                  <a:srgbClr val="F0C860"/>
+                </a:solidFill>
+                <a:latin typeface="Segoe UI"/>
+              </a:rPr>
+              <a:t>• الخبرة المؤسسية المتراكمة: </a:t>
+            </a:r>
+            <a:r>
+              <a:rPr sz="1150">
+                <a:solidFill>
+                  <a:srgbClr val="F8FAFC"/>
+                </a:solidFill>
+                <a:latin typeface="Segoe UI"/>
+              </a:rPr>
+              <a:t>50 عاماً لهيئة الصرف (EPADP) في تنفيذ 6 ملايين فدان تقضي تماماً على مخاطر التنفيذ.</a:t>
+            </a:r>
+          </a:p>
+          <a:p>
+            <a:pPr algn="r">
+              <a:lnSpc>
+                <a:spcPct val="125000"/>
+              </a:lnSpc>
+              <a:spcAft>
+                <a:spcPts val="500"/>
+              </a:spcAft>
+            </a:pPr>
+            <a:r>
+              <a:rPr sz="1150" b="1">
+                <a:solidFill>
+                  <a:srgbClr val="10B981"/>
+                </a:solidFill>
+                <a:latin typeface="Segoe UI"/>
+              </a:rPr>
+              <a:t>• وحدة الاختبار الحقلية (10 أفدنة): </a:t>
+            </a:r>
+            <a:r>
+              <a:rPr sz="1150">
+                <a:solidFill>
+                  <a:srgbClr val="F8FAFC"/>
+                </a:solidFill>
+                <a:latin typeface="Segoe UI"/>
+              </a:rPr>
+              <a:t>تصميم هندسي متكامل جاهز للتنفيذ الفوري لاختبار الصعود الشعري والصمامات الذكية.</a:t>
+            </a:r>
+          </a:p>
+          <a:p>
+            <a:pPr algn="r">
+              <a:lnSpc>
+                <a:spcPct val="125000"/>
+              </a:lnSpc>
+              <a:spcAft>
+                <a:spcPts val="500"/>
+              </a:spcAft>
+            </a:pPr>
+            <a:r>
+              <a:rPr sz="1150" b="1">
+                <a:solidFill>
+                  <a:srgbClr val="10B981"/>
+                </a:solidFill>
+                <a:latin typeface="Segoe UI"/>
+              </a:rPr>
+              <a:t>• الجاهزية التكنولوجية (TRL 8-9): </a:t>
+            </a:r>
+            <a:r>
+              <a:rPr sz="1150">
+                <a:solidFill>
+                  <a:srgbClr val="F8FAFC"/>
+                </a:solidFill>
+                <a:latin typeface="Segoe UI"/>
+              </a:rPr>
+              <a:t>نضج تجاري كامل لمواسير HDPE والمحطات الشمسية وحساسات NB-IoT.</a:t>
+            </a:r>
+          </a:p>
+          <a:p>
+            <a:pPr algn="r">
+              <a:lnSpc>
+                <a:spcPct val="125000"/>
+              </a:lnSpc>
+              <a:spcAft>
+                <a:spcPts val="0"/>
+              </a:spcAft>
+            </a:pPr>
+            <a:r>
+              <a:rPr sz="1150" b="1">
+                <a:solidFill>
+                  <a:srgbClr val="F0C860"/>
+                </a:solidFill>
+                <a:latin typeface="Segoe UI"/>
+              </a:rPr>
+              <a:t>• الخطوة التنفيذية الفورية: </a:t>
+            </a:r>
+            <a:r>
+              <a:rPr sz="1150">
+                <a:solidFill>
+                  <a:srgbClr val="F8FAFC"/>
+                </a:solidFill>
+                <a:latin typeface="Segoe UI"/>
+              </a:rPr>
+              <a:t>طلب منحة تحضيرية (PPF Grant بقيمة 1.5M$) من GCF/AfDB لدراسات كفر الشيخ.</a:t>
+            </a:r>
+          </a:p>
+        </p:txBody>
+      </p:sp>
+      <p:sp>
+        <p:nvSpPr>
+          <p:cNvPr id="14" name="Rounded Rectangle 13"/>
+          <p:cNvSpPr/>
+          <p:nvPr/>
+        </p:nvSpPr>
+        <p:spPr>
+          <a:xfrm>
+            <a:off x="6217920" y="4069080"/>
+            <a:ext cx="5242255" cy="2423160"/>
+          </a:xfrm>
+          <a:prstGeom prst="roundRect">
+            <a:avLst>
+              <a:gd name="adj" fmla="val 8000"/>
+            </a:avLst>
+          </a:prstGeom>
+          <a:solidFill>
+            <a:srgbClr val="0F2240"/>
+          </a:solidFill>
+          <a:ln w="16510">
+            <a:solidFill>
+              <a:srgbClr val="15B5A4"/>
+            </a:solidFill>
+          </a:ln>
+        </p:spPr>
+        <p:style>
+          <a:lnRef idx="1">
+            <a:schemeClr val="accent1"/>
+          </a:lnRef>
+          <a:fillRef idx="3">
+            <a:schemeClr val="accent1"/>
+          </a:fillRef>
+          <a:effectRef idx="2">
+            <a:schemeClr val="accent1"/>
+          </a:effectRef>
+          <a:fontRef idx="minor">
+            <a:schemeClr val="lt1"/>
+          </a:fontRef>
+        </p:style>
+        <p:txBody>
+          <a:bodyPr rtlCol="0" anchor="ctr"/>
+          <a:lstStyle/>
+          <a:p>
+            <a:pPr algn="ctr"/>
+          </a:p>
+        </p:txBody>
+      </p:sp>
+      <p:sp>
+        <p:nvSpPr>
+          <p:cNvPr id="15" name="TextBox 14"/>
+          <p:cNvSpPr txBox="1"/>
+          <p:nvPr/>
+        </p:nvSpPr>
+        <p:spPr>
+          <a:xfrm>
+            <a:off x="6419088" y="4178808"/>
+            <a:ext cx="4839919" cy="347472"/>
+          </a:xfrm>
+          <a:prstGeom prst="rect">
+            <a:avLst/>
+          </a:prstGeom>
+          <a:noFill/>
+        </p:spPr>
+        <p:txBody>
+          <a:bodyPr wrap="square" tIns="0" bIns="0" lIns="0" rIns="0">
+            <a:spAutoFit/>
+          </a:bodyPr>
+          <a:lstStyle/>
+          <a:p>
+            <a:pPr algn="r">
+              <a:defRPr sz="1450" b="1">
+                <a:solidFill>
+                  <a:srgbClr val="15B5A4"/>
+                </a:solidFill>
+                <a:latin typeface="Segoe UI"/>
+              </a:defRPr>
+            </a:pPr>
+            <a:r>
+              <a:t>🎯 3. تحليل ملاءمة جهات التمويل (Funding Fit)</a:t>
+            </a:r>
+          </a:p>
+        </p:txBody>
+      </p:sp>
+      <p:sp>
+        <p:nvSpPr>
+          <p:cNvPr id="16" name="Rounded Rectangle 15"/>
+          <p:cNvSpPr/>
+          <p:nvPr/>
+        </p:nvSpPr>
+        <p:spPr>
+          <a:xfrm>
+            <a:off x="6400800" y="4507992"/>
+            <a:ext cx="4876495" cy="310896"/>
+          </a:xfrm>
+          <a:prstGeom prst="roundRect">
+            <a:avLst>
+              <a:gd name="adj" fmla="val 35000"/>
+            </a:avLst>
+          </a:prstGeom>
+          <a:solidFill>
+            <a:srgbClr val="162D52"/>
           </a:solidFill>
           <a:ln w="12700">
             <a:solidFill>
@@ -4408,23 +6622,33 @@
           </a:fontRef>
         </p:style>
         <p:txBody>
-          <a:bodyPr rtlCol="0" anchor="ctr"/>
-          <a:lstStyle/>
-          <a:p>
-            <a:pPr algn="ctr"/>
-          </a:p>
-        </p:txBody>
-      </p:sp>
-      <p:sp>
-        <p:nvSpPr>
-          <p:cNvPr id="5" name="TextBox 4"/>
+          <a:bodyPr rtlCol="0" anchor="ctr" wrap="square" tIns="0" bIns="0" lIns="0" rIns="0"/>
+          <a:lstStyle/>
+          <a:p>
+            <a:pPr algn="r">
+              <a:defRPr sz="1150" b="1">
+                <a:solidFill>
+                  <a:srgbClr val="F0C860"/>
+                </a:solidFill>
+                <a:latin typeface="Segoe UI"/>
+              </a:defRPr>
+            </a:pPr>
+            <a:r>
+              <a:t> صندوق المناخ GCF: 14/14 (GO) | صندوق التكيف: 13/14 </a:t>
+            </a:r>
+          </a:p>
+        </p:txBody>
+      </p:sp>
+      <p:sp>
+        <p:nvSpPr>
+          <p:cNvPr id="17" name="TextBox 16"/>
           <p:cNvSpPr txBox="1"/>
           <p:nvPr/>
         </p:nvSpPr>
         <p:spPr>
           <a:xfrm>
-            <a:off x="6400800" y="1600200"/>
-            <a:ext cx="4876495" cy="365760"/>
+            <a:off x="6419088" y="4873752"/>
+            <a:ext cx="4839919" cy="1527048"/>
           </a:xfrm>
           <a:prstGeom prst="rect">
             <a:avLst/>
@@ -4438,133 +6662,112 @@
           <a:lstStyle/>
           <a:p>
             <a:pPr algn="r">
-              <a:defRPr sz="1200" b="1">
+              <a:lnSpc>
+                <a:spcPct val="125000"/>
+              </a:lnSpc>
+              <a:spcAft>
+                <a:spcPts val="600"/>
+              </a:spcAft>
+            </a:pPr>
+            <a:r>
+              <a:rPr sz="1150" b="1">
                 <a:solidFill>
                   <a:srgbClr val="F0C860"/>
                 </a:solidFill>
-              </a:defRPr>
-            </a:pPr>
-            <a:r>
-              <a:t>💰 1. إجمالي التكلفة (420M$) وهيكل رأس المال المختلط</a:t>
-            </a:r>
-          </a:p>
-        </p:txBody>
-      </p:sp>
-      <p:sp>
-        <p:nvSpPr>
-          <p:cNvPr id="6" name="TextBox 5"/>
-          <p:cNvSpPr txBox="1"/>
-          <p:nvPr/>
-        </p:nvSpPr>
-        <p:spPr>
-          <a:xfrm>
-            <a:off x="6400800" y="1965960"/>
-            <a:ext cx="4876495" cy="1965960"/>
-          </a:xfrm>
-          <a:prstGeom prst="rect">
-            <a:avLst/>
-          </a:prstGeom>
-          <a:noFill/>
-        </p:spPr>
-        <p:txBody>
-          <a:bodyPr wrap="square" tIns="0" bIns="0" lIns="0" rIns="0">
-            <a:spAutoFit/>
-          </a:bodyPr>
-          <a:lstStyle/>
+                <a:latin typeface="Segoe UI"/>
+              </a:rPr>
+              <a:t>• صندوق المناخ الأخضر (GCF): </a:t>
+            </a:r>
+            <a:r>
+              <a:rPr sz="1150">
+                <a:solidFill>
+                  <a:srgbClr val="F8FAFC"/>
+                </a:solidFill>
+                <a:latin typeface="Segoe UI"/>
+              </a:rPr>
+              <a:t>درجة 14/14 (قرار: GO) — تطابق كامل مع نافذة التكيف وتخفيف الانبعاثات والتحول الرقمي.</a:t>
+            </a:r>
+          </a:p>
           <a:p>
             <a:pPr algn="r">
-              <a:defRPr sz="880">
+              <a:lnSpc>
+                <a:spcPct val="125000"/>
+              </a:lnSpc>
+              <a:spcAft>
+                <a:spcPts val="600"/>
+              </a:spcAft>
+            </a:pPr>
+            <a:r>
+              <a:rPr sz="1150" b="1">
+                <a:solidFill>
+                  <a:srgbClr val="15B5A4"/>
+                </a:solidFill>
+                <a:latin typeface="Segoe UI"/>
+              </a:rPr>
+              <a:t>• صندوق التكيف (Adaptation Fund): </a:t>
+            </a:r>
+            <a:r>
+              <a:rPr sz="1150">
                 <a:solidFill>
                   <a:srgbClr val="F8FAFC"/>
                 </a:solidFill>
-              </a:defRPr>
-            </a:pPr>
-            <a:r>
-              <a:t>• إجمالي الاستثمار: 420 مليون دولار (4,200 دولار/فدان لكافة العناصر الهندسية والتقنية والبيئية).</a:t>
+                <a:latin typeface="Segoe UI"/>
+              </a:rPr>
+              <a:t>درجة 13/14 (قرار: GO) — مثالي لتمويل الحقل التجريبي وبناء القدرات المجتمعية.</a:t>
             </a:r>
           </a:p>
           <a:p>
             <a:pPr algn="r">
-              <a:defRPr sz="880">
+              <a:lnSpc>
+                <a:spcPct val="125000"/>
+              </a:lnSpc>
+              <a:spcAft>
+                <a:spcPts val="0"/>
+              </a:spcAft>
+            </a:pPr>
+            <a:r>
+              <a:rPr sz="1150" b="1">
+                <a:solidFill>
+                  <a:srgbClr val="15B5A4"/>
+                </a:solidFill>
+                <a:latin typeface="Segoe UI"/>
+              </a:rPr>
+              <a:t>• برنامج PRIMA وبوابة الاتحاد الأوروبي: </a:t>
+            </a:r>
+            <a:r>
+              <a:rPr sz="1150">
                 <a:solidFill>
                   <a:srgbClr val="F8FAFC"/>
                 </a:solidFill>
-              </a:defRPr>
-            </a:pPr>
-            <a:r>
-              <a:t>• 15% منح ومساعدات فنية (63M$): من GCF و AfDB و EU للحقل التجريبي والمنصة ودراسات الجدوى.</a:t>
-            </a:r>
-          </a:p>
-          <a:p>
-            <a:pPr algn="r">
-              <a:defRPr sz="880">
-                <a:solidFill>
-                  <a:srgbClr val="F8FAFC"/>
-                </a:solidFill>
-              </a:defRPr>
-            </a:pPr>
-            <a:r>
-              <a:t>• 20% مساهمة حكومية عينية (84M$): أراضٍ ومحطات طلمبات قائمة وكوادر هيئة الصرف.</a:t>
-            </a:r>
-          </a:p>
-          <a:p>
-            <a:pPr algn="r">
-              <a:defRPr sz="880">
-                <a:solidFill>
-                  <a:srgbClr val="F8FAFC"/>
-                </a:solidFill>
-              </a:defRPr>
-            </a:pPr>
-            <a:r>
-              <a:t>• 40% قروض ميسرة (168M$): البنك الدولي (NDP V)، وبنك التنمية الأفريقي (سداد 20-25 سنة).</a:t>
-            </a:r>
-          </a:p>
-          <a:p>
-            <a:pPr algn="r">
-              <a:defRPr sz="880">
-                <a:solidFill>
-                  <a:srgbClr val="F8FAFC"/>
-                </a:solidFill>
-              </a:defRPr>
-            </a:pPr>
-            <a:r>
-              <a:t>• 25% قروض تجارية وشراكة PPP (105M$): لمكون الطاقة الشمسية 50 MW مدعوماً باتفاقيات PPA.</a:t>
-            </a:r>
-          </a:p>
-          <a:p>
-            <a:pPr algn="r">
-              <a:defRPr sz="880">
-                <a:solidFill>
-                  <a:srgbClr val="F8FAFC"/>
-                </a:solidFill>
-              </a:defRPr>
-            </a:pPr>
-            <a:r>
-              <a:t>• مؤشرات الربحية الاقتصادية: EIRR = 21.4% | DSCR = 1.35x (تحت الضغط) | استرداد 8 سنوات.</a:t>
-            </a:r>
-          </a:p>
-        </p:txBody>
-      </p:sp>
-      <p:sp>
-        <p:nvSpPr>
-          <p:cNvPr id="7" name="Rounded Rectangle 6"/>
+                <a:latin typeface="Segoe UI"/>
+              </a:rPr>
+              <a:t>ملاءمة مرتفعة جداً للابتكار الزراعي المائي والتعاون الإقليمي الأورومتوسطي.</a:t>
+            </a:r>
+          </a:p>
+        </p:txBody>
+      </p:sp>
+      <p:sp>
+        <p:nvSpPr>
+          <p:cNvPr id="18" name="Rounded Rectangle 17"/>
           <p:cNvSpPr/>
           <p:nvPr/>
         </p:nvSpPr>
         <p:spPr>
           <a:xfrm>
-            <a:off x="6217920" y="4160520"/>
-            <a:ext cx="5242255" cy="2240280"/>
+            <a:off x="731520" y="4069080"/>
+            <a:ext cx="5212080" cy="2423160"/>
           </a:xfrm>
           <a:prstGeom prst="roundRect">
-            <a:avLst/>
+            <a:avLst>
+              <a:gd name="adj" fmla="val 8000"/>
+            </a:avLst>
           </a:prstGeom>
           <a:solidFill>
             <a:srgbClr val="0F2240"/>
           </a:solidFill>
-          <a:ln w="12700">
+          <a:ln w="16510">
             <a:solidFill>
-              <a:srgbClr val="15B5A4"/>
+              <a:srgbClr val="F8FAFC"/>
             </a:solidFill>
           </a:ln>
         </p:spPr>
@@ -4592,14 +6795,14 @@
       </p:sp>
       <p:sp>
         <p:nvSpPr>
-          <p:cNvPr id="8" name="TextBox 7"/>
+          <p:cNvPr id="19" name="TextBox 18"/>
           <p:cNvSpPr txBox="1"/>
           <p:nvPr/>
         </p:nvSpPr>
         <p:spPr>
           <a:xfrm>
-            <a:off x="6400800" y="4297680"/>
-            <a:ext cx="4876495" cy="365760"/>
+            <a:off x="932688" y="4178808"/>
+            <a:ext cx="4809744" cy="347472"/>
           </a:xfrm>
           <a:prstGeom prst="rect">
             <a:avLst/>
@@ -4613,97 +6816,41 @@
           <a:lstStyle/>
           <a:p>
             <a:pPr algn="r">
-              <a:defRPr sz="1200" b="1">
-                <a:solidFill>
-                  <a:srgbClr val="15B5A4"/>
-                </a:solidFill>
+              <a:defRPr sz="1450" b="1">
+                <a:solidFill>
+                  <a:srgbClr val="F8FAFC"/>
+                </a:solidFill>
+                <a:latin typeface="Segoe UI"/>
               </a:defRPr>
             </a:pPr>
             <a:r>
-              <a:t>🎯 2. تحليل ملاءمة جهات التمويل (Funding Call Fit)</a:t>
-            </a:r>
-          </a:p>
-        </p:txBody>
-      </p:sp>
-      <p:sp>
-        <p:nvSpPr>
-          <p:cNvPr id="9" name="TextBox 8"/>
-          <p:cNvSpPr txBox="1"/>
-          <p:nvPr/>
-        </p:nvSpPr>
-        <p:spPr>
-          <a:xfrm>
-            <a:off x="6400800" y="4663440"/>
-            <a:ext cx="4876495" cy="1645920"/>
-          </a:xfrm>
-          <a:prstGeom prst="rect">
-            <a:avLst/>
-          </a:prstGeom>
-          <a:noFill/>
-        </p:spPr>
-        <p:txBody>
-          <a:bodyPr wrap="square" tIns="0" bIns="0" lIns="0" rIns="0">
-            <a:spAutoFit/>
-          </a:bodyPr>
-          <a:lstStyle/>
-          <a:p>
-            <a:pPr algn="r">
-              <a:defRPr sz="880">
-                <a:solidFill>
-                  <a:srgbClr val="F8FAFC"/>
-                </a:solidFill>
-              </a:defRPr>
-            </a:pPr>
-            <a:r>
-              <a:t>• صندوق المناخ الأخضر (GCF Adaptation): درجة 14/14 (قرار: GO) - تطابق كامل مع نافذة التكيف والتخفيف والتحول الرقمي.</a:t>
-            </a:r>
-          </a:p>
-          <a:p>
-            <a:pPr algn="r">
-              <a:defRPr sz="880">
-                <a:solidFill>
-                  <a:srgbClr val="F8FAFC"/>
-                </a:solidFill>
-              </a:defRPr>
-            </a:pPr>
-            <a:r>
-              <a:t>• صندوق التكيف (Adaptation Fund): درجة 13/14 (قرار: GO لمقترح مجزأ أو الحقل التجريبي 10 أفدنة).</a:t>
-            </a:r>
-          </a:p>
-          <a:p>
-            <a:pPr algn="r">
-              <a:defRPr sz="880">
-                <a:solidFill>
-                  <a:srgbClr val="F8FAFC"/>
-                </a:solidFill>
-              </a:defRPr>
-            </a:pPr>
-            <a:r>
-              <a:t>• برنامج PRIMA وبوابة الاتحاد الأوروبي: ملاءمة مرتفعة جداً للتحول الرقمي الزراعي والتعاون الأورومتوسطي.</a:t>
-            </a:r>
-          </a:p>
-        </p:txBody>
-      </p:sp>
-      <p:sp>
-        <p:nvSpPr>
-          <p:cNvPr id="10" name="Rounded Rectangle 9"/>
+              <a:t>📈 4. مؤشرات الأداء الرئيسية ومسار التوسع الإقليمي</a:t>
+            </a:r>
+          </a:p>
+        </p:txBody>
+      </p:sp>
+      <p:sp>
+        <p:nvSpPr>
+          <p:cNvPr id="20" name="Rounded Rectangle 19"/>
           <p:cNvSpPr/>
           <p:nvPr/>
         </p:nvSpPr>
         <p:spPr>
           <a:xfrm>
-            <a:off x="731520" y="1463040"/>
-            <a:ext cx="5212080" cy="2240280"/>
+            <a:off x="914400" y="4507992"/>
+            <a:ext cx="4846320" cy="310896"/>
           </a:xfrm>
           <a:prstGeom prst="roundRect">
-            <a:avLst/>
+            <a:avLst>
+              <a:gd name="adj" fmla="val 35000"/>
+            </a:avLst>
           </a:prstGeom>
           <a:solidFill>
-            <a:srgbClr val="0F2240"/>
+            <a:srgbClr val="162D52"/>
           </a:solidFill>
           <a:ln w="12700">
             <a:solidFill>
-              <a:srgbClr val="15B5A4"/>
+              <a:srgbClr val="F8FAFC"/>
             </a:solidFill>
           </a:ln>
         </p:spPr>
@@ -4722,23 +6869,33 @@
           </a:fontRef>
         </p:style>
         <p:txBody>
-          <a:bodyPr rtlCol="0" anchor="ctr"/>
-          <a:lstStyle/>
-          <a:p>
-            <a:pPr algn="ctr"/>
-          </a:p>
-        </p:txBody>
-      </p:sp>
-      <p:sp>
-        <p:nvSpPr>
-          <p:cNvPr id="11" name="TextBox 10"/>
+          <a:bodyPr rtlCol="0" anchor="ctr" wrap="square" tIns="0" bIns="0" lIns="0" rIns="0"/>
+          <a:lstStyle/>
+          <a:p>
+            <a:pPr algn="r">
+              <a:defRPr sz="1150" b="1">
+                <a:solidFill>
+                  <a:srgbClr val="F0C860"/>
+                </a:solidFill>
+                <a:latin typeface="Segoe UI"/>
+              </a:defRPr>
+            </a:pPr>
+            <a:r>
+              <a:t> وفر 150M م³ | +25% غلة | 50 MW طاقة | 100k طن كربون </a:t>
+            </a:r>
+          </a:p>
+        </p:txBody>
+      </p:sp>
+      <p:sp>
+        <p:nvSpPr>
+          <p:cNvPr id="21" name="TextBox 20"/>
           <p:cNvSpPr txBox="1"/>
           <p:nvPr/>
         </p:nvSpPr>
         <p:spPr>
           <a:xfrm>
-            <a:off x="914400" y="1600200"/>
-            <a:ext cx="4846320" cy="365760"/>
+            <a:off x="932688" y="4873752"/>
+            <a:ext cx="4809744" cy="1527048"/>
           </a:xfrm>
           <a:prstGeom prst="rect">
             <a:avLst/>
@@ -4752,272 +6909,86 @@
           <a:lstStyle/>
           <a:p>
             <a:pPr algn="r">
-              <a:defRPr sz="1200" b="1">
-                <a:solidFill>
-                  <a:srgbClr val="10B981"/>
-                </a:solidFill>
-              </a:defRPr>
-            </a:pPr>
-            <a:r>
-              <a:t>🚀 3. حالة الجاهزية ووحدة الاختبار (10 أفدنة)</a:t>
-            </a:r>
-          </a:p>
-        </p:txBody>
-      </p:sp>
-      <p:sp>
-        <p:nvSpPr>
-          <p:cNvPr id="12" name="TextBox 11"/>
-          <p:cNvSpPr txBox="1"/>
-          <p:nvPr/>
-        </p:nvSpPr>
-        <p:spPr>
-          <a:xfrm>
-            <a:off x="914400" y="1965960"/>
-            <a:ext cx="4846320" cy="1645920"/>
-          </a:xfrm>
-          <a:prstGeom prst="rect">
-            <a:avLst/>
-          </a:prstGeom>
-          <a:noFill/>
-        </p:spPr>
-        <p:txBody>
-          <a:bodyPr wrap="square" tIns="0" bIns="0" lIns="0" rIns="0">
-            <a:spAutoFit/>
-          </a:bodyPr>
-          <a:lstStyle/>
+              <a:lnSpc>
+                <a:spcPct val="125000"/>
+              </a:lnSpc>
+              <a:spcAft>
+                <a:spcPts val="600"/>
+              </a:spcAft>
+            </a:pPr>
+            <a:r>
+              <a:rPr sz="1150" b="1">
+                <a:solidFill>
+                  <a:srgbClr val="F0C860"/>
+                </a:solidFill>
+                <a:latin typeface="Segoe UI"/>
+              </a:rPr>
+              <a:t>• مؤشرات الأداء (100,000 فدان): </a:t>
+            </a:r>
+            <a:r>
+              <a:rPr sz="1150">
+                <a:solidFill>
+                  <a:srgbClr val="F8FAFC"/>
+                </a:solidFill>
+                <a:latin typeface="Segoe UI"/>
+              </a:rPr>
+              <a:t>150M م³/سنة وفر مائي • +15-25% غلة المحاصيل • 50 MW طاقة نظيفة.</a:t>
+            </a:r>
+          </a:p>
           <a:p>
             <a:pPr algn="r">
-              <a:defRPr sz="880">
+              <a:lnSpc>
+                <a:spcPct val="125000"/>
+              </a:lnSpc>
+              <a:spcAft>
+                <a:spcPts val="600"/>
+              </a:spcAft>
+            </a:pPr>
+            <a:r>
+              <a:rPr sz="1150" b="1">
                 <a:solidFill>
                   <a:srgbClr val="F8FAFC"/>
                 </a:solidFill>
-              </a:defRPr>
-            </a:pPr>
-            <a:r>
-              <a:t>• النضج المؤسسي والتنفيذي: خبرة 50 عاماً لهيئة الصرف (EPADP) في شبكات 6 ملايين فدان تقضي على المخاطر التنفيذية.</a:t>
+                <a:latin typeface="Segoe UI"/>
+              </a:rPr>
+              <a:t>• الردع والاستدامة: </a:t>
+            </a:r>
+            <a:r>
+              <a:rPr sz="1150">
+                <a:solidFill>
+                  <a:srgbClr val="F8FAFC"/>
+                </a:solidFill>
+                <a:latin typeface="Segoe UI"/>
+              </a:rPr>
+              <a:t>خفض التعديات 80% • كشف الأعطال في ساعة واحدة • احتجاز 100,000 طن CO₂ سنوياً.</a:t>
             </a:r>
           </a:p>
           <a:p>
             <a:pPr algn="r">
-              <a:defRPr sz="880">
+              <a:lnSpc>
+                <a:spcPct val="125000"/>
+              </a:lnSpc>
+              <a:spcAft>
+                <a:spcPts val="0"/>
+              </a:spcAft>
+            </a:pPr>
+            <a:r>
+              <a:rPr sz="1100" b="1">
+                <a:solidFill>
+                  <a:srgbClr val="15B5A4"/>
+                </a:solidFill>
+                <a:latin typeface="Segoe UI"/>
+              </a:rPr>
+              <a:t>• مسار التوسع الإقليمي (3 مراحل): </a:t>
+            </a:r>
+            <a:r>
+              <a:rPr sz="1100">
                 <a:solidFill>
                   <a:srgbClr val="F8FAFC"/>
                 </a:solidFill>
-              </a:defRPr>
-            </a:pPr>
-            <a:r>
-              <a:t>• وحدة الاختبار الحقلية (10 أفدنة): تصميم جاهز للتنفيذ الفوري على مجمع صرف مستقل لاختبار الصعود الشعري قبل التعميم.</a:t>
-            </a:r>
-          </a:p>
-          <a:p>
-            <a:pPr algn="r">
-              <a:defRPr sz="880">
-                <a:solidFill>
-                  <a:srgbClr val="F8FAFC"/>
-                </a:solidFill>
-              </a:defRPr>
-            </a:pPr>
-            <a:r>
-              <a:t>• نضج التقنيات (TRL): مستوى TRL 8-9 لكافة مكونات HDPE والطاقة الشمسية وحساسات ESP32 و NB-IoT.</a:t>
-            </a:r>
-          </a:p>
-          <a:p>
-            <a:pPr algn="r">
-              <a:defRPr sz="880">
-                <a:solidFill>
-                  <a:srgbClr val="F8FAFC"/>
-                </a:solidFill>
-              </a:defRPr>
-            </a:pPr>
-            <a:r>
-              <a:t>• الخطوة التنفيذية الفورية: طلب منحة تحضيرية (PPF Grant بقيمة 1.5 مليون دولار) من GCF/AfDB لدراسات كفر الشيخ.</a:t>
-            </a:r>
-          </a:p>
-        </p:txBody>
-      </p:sp>
-      <p:sp>
-        <p:nvSpPr>
-          <p:cNvPr id="13" name="Rounded Rectangle 12"/>
-          <p:cNvSpPr/>
-          <p:nvPr/>
-        </p:nvSpPr>
-        <p:spPr>
-          <a:xfrm>
-            <a:off x="731520" y="3840480"/>
-            <a:ext cx="5212080" cy="2560320"/>
-          </a:xfrm>
-          <a:prstGeom prst="roundRect">
-            <a:avLst/>
-          </a:prstGeom>
-          <a:solidFill>
-            <a:srgbClr val="0F2240"/>
-          </a:solidFill>
-          <a:ln w="12700">
-            <a:solidFill>
-              <a:srgbClr val="15B5A4"/>
-            </a:solidFill>
-          </a:ln>
-        </p:spPr>
-        <p:style>
-          <a:lnRef idx="1">
-            <a:schemeClr val="accent1"/>
-          </a:lnRef>
-          <a:fillRef idx="3">
-            <a:schemeClr val="accent1"/>
-          </a:fillRef>
-          <a:effectRef idx="2">
-            <a:schemeClr val="accent1"/>
-          </a:effectRef>
-          <a:fontRef idx="minor">
-            <a:schemeClr val="lt1"/>
-          </a:fontRef>
-        </p:style>
-        <p:txBody>
-          <a:bodyPr rtlCol="0" anchor="ctr"/>
-          <a:lstStyle/>
-          <a:p>
-            <a:pPr algn="ctr"/>
-          </a:p>
-        </p:txBody>
-      </p:sp>
-      <p:sp>
-        <p:nvSpPr>
-          <p:cNvPr id="14" name="TextBox 13"/>
-          <p:cNvSpPr txBox="1"/>
-          <p:nvPr/>
-        </p:nvSpPr>
-        <p:spPr>
-          <a:xfrm>
-            <a:off x="914400" y="3977640"/>
-            <a:ext cx="4846320" cy="365760"/>
-          </a:xfrm>
-          <a:prstGeom prst="rect">
-            <a:avLst/>
-          </a:prstGeom>
-          <a:noFill/>
-        </p:spPr>
-        <p:txBody>
-          <a:bodyPr wrap="square" tIns="0" bIns="0" lIns="0" rIns="0">
-            <a:spAutoFit/>
-          </a:bodyPr>
-          <a:lstStyle/>
-          <a:p>
-            <a:pPr algn="r">
-              <a:defRPr sz="1200" b="1">
-                <a:solidFill>
-                  <a:srgbClr val="F8FAFC"/>
-                </a:solidFill>
-              </a:defRPr>
-            </a:pPr>
-            <a:r>
-              <a:t>📈 4. مؤشرات الأداء الرئيسية ومسار التوسع الإقليمي</a:t>
-            </a:r>
-          </a:p>
-        </p:txBody>
-      </p:sp>
-      <p:sp>
-        <p:nvSpPr>
-          <p:cNvPr id="15" name="TextBox 14"/>
-          <p:cNvSpPr txBox="1"/>
-          <p:nvPr/>
-        </p:nvSpPr>
-        <p:spPr>
-          <a:xfrm>
-            <a:off x="914400" y="4343400"/>
-            <a:ext cx="4846320" cy="1965960"/>
-          </a:xfrm>
-          <a:prstGeom prst="rect">
-            <a:avLst/>
-          </a:prstGeom>
-          <a:noFill/>
-        </p:spPr>
-        <p:txBody>
-          <a:bodyPr wrap="square" tIns="0" bIns="0" lIns="0" rIns="0">
-            <a:spAutoFit/>
-          </a:bodyPr>
-          <a:lstStyle/>
-          <a:p>
-            <a:pPr algn="r">
-              <a:defRPr sz="850">
-                <a:solidFill>
-                  <a:srgbClr val="F0C860"/>
-                </a:solidFill>
-              </a:defRPr>
-            </a:pPr>
-            <a:r>
-              <a:t>مؤشرات الأداء الكمية المستهدفة (100,000 فدان): </a:t>
-            </a:r>
-          </a:p>
-          <a:p>
-            <a:pPr algn="r">
-              <a:defRPr sz="850">
-                <a:solidFill>
-                  <a:srgbClr val="F8FAFC"/>
-                </a:solidFill>
-              </a:defRPr>
-            </a:pPr>
-            <a:r>
-              <a:t>• 150 مليون م³/سنة وفر مائي عبر الصرف المحكوم والصعود الشعري.</a:t>
-            </a:r>
-          </a:p>
-          <a:p>
-            <a:pPr algn="r">
-              <a:defRPr sz="850">
-                <a:solidFill>
-                  <a:srgbClr val="F8FAFC"/>
-                </a:solidFill>
-              </a:defRPr>
-            </a:pPr>
-            <a:r>
-              <a:t>• 15-25% زيادة إنتاجية المحاصيل لأكثر من 200,000 مزارع مستفيد.</a:t>
-            </a:r>
-          </a:p>
-          <a:p>
-            <a:pPr algn="r">
-              <a:defRPr sz="850">
-                <a:solidFill>
-                  <a:srgbClr val="F8FAFC"/>
-                </a:solidFill>
-              </a:defRPr>
-            </a:pPr>
-            <a:r>
-              <a:t>• 50 MW طاقة شمسية و 90 GWh/سنة كهرباء نظيفة + خفض 40% من تكلفة الضخ.</a:t>
-            </a:r>
-          </a:p>
-          <a:p>
-            <a:pPr algn="r">
-              <a:defRPr sz="850">
-                <a:solidFill>
-                  <a:srgbClr val="F8FAFC"/>
-                </a:solidFill>
-              </a:defRPr>
-            </a:pPr>
-            <a:r>
-              <a:t>• خفض التعديات 80% وكشف الأعطال في ساعة واحدة بدلاً من أسابيع.</a:t>
-            </a:r>
-          </a:p>
-          <a:p>
-            <a:pPr algn="r">
-              <a:defRPr sz="850">
-                <a:solidFill>
-                  <a:srgbClr val="F8FAFC"/>
-                </a:solidFill>
-              </a:defRPr>
-            </a:pPr>
-            <a:r>
-              <a:t>• خفض 100,000 طن CO₂/سنة وتوفير 5,000 فرصة عمل مباشرة.</a:t>
-            </a:r>
-          </a:p>
-          <a:p>
-            <a:pPr algn="r">
-              <a:defRPr sz="850">
-                <a:solidFill>
-                  <a:srgbClr val="F0C860"/>
-                </a:solidFill>
-              </a:defRPr>
-            </a:pPr>
-            <a:r>
-              <a:t>مسار التوسع (3 مراحل): حقل تجريبي 10 أفدنة (سنة 1) -&gt; تجربة ريادية 100 ألف فدان (سنوات 2-5) -&gt; تعميم عبر 4.3M فدان بالدلتا ونقل التجربة إقليمياً للعراق والأردن وباكستان.</a:t>
+                <a:latin typeface="Segoe UI"/>
+              </a:rPr>
+              <a:t>حقل تجريبي 10 أفدنة (سنة 1) ⬅️ مشروع ريادي 100 ألف فدان (سنوات 2-5) ⬅️ تعميم عبر 4.3M فدان بالدلتا ونقل التجربة للعراق والأردن وباكستان.</a:t>
             </a:r>
           </a:p>
         </p:txBody>

</xml_diff>

<commit_message>
feat(web): regenerate 5-min slides from shared bilingual content (RTL/LTR, images, animation) to match PPTX
</commit_message>
<xml_diff>
--- a/Eco-Drain_WEFE_Nexus_5Min_Pitch.pptx
+++ b/Eco-Drain_WEFE_Nexus_5Min_Pitch.pptx
@@ -6927,7 +6927,7 @@
                   <a:ea typeface="Segoe UI"/>
                   <a:cs typeface="Segoe UI"/>
                 </a:rPr>
-                <a:t>50 MW شمسية · 90 GWh سنوياً</a:t>
+                <a:t>50 ميجاوات · 90 جيجاواط ساعة</a:t>
               </a:r>
             </a:p>
           </p:txBody>
@@ -6971,7 +6971,7 @@
                   <a:ea typeface="Segoe UI"/>
                   <a:cs typeface="Segoe UI"/>
                 </a:rPr>
-                <a:t>طاقة موزعة على 25 محطة رفع تخفض فاتورة الضخ 40% وتصدّر الفائض بنظام صافي القياس.</a:t>
+                <a:t>طاقة شمسية موزعة على 25 محطة رفع تخفض فاتورة الضخ 40% وتصدّر الفائض بنظام صافي القياس.</a:t>
               </a:r>
             </a:p>
           </p:txBody>

</xml_diff>